<commit_message>
Fix 1 flashed and accepted on RG too; deck and manual say both radios
Co-Authored-By: Claude Fable 5.1 <noreply@anthropic.com>
</commit_message>
<xml_diff>
--- a/docs/presentations/Group9_Presentation.pptx
+++ b/docs/presentations/Group9_Presentation.pptx
@@ -1151,7 +1151,7 @@
           <a:lstStyle/>
           <a:p>
             <a:r>
-              <a:t>Fix 1 is the community's own answer to #4555 and costs one build per radio: build Meshtastic from source with a userPrefs.jsonc that names our channel, key, region, role, owner names, cadence, plus a one-line patch so the default Bluetooth mode is No PIN. Acceptance on SF, 28 October: after a factory reset the radio was already configured; the snapshot then restored the smart-broadcast minimums (10 s / 20 m), the 21 presets and the original key pair. The ask: approve the flat-battery campaign before the next field test. Fix 2 removes the cause; fix 3 cleans up the past; fix 4 is the hardware-correct answer and the most work.</a:t>
+              <a:t>Fix 1 is the community's own answer to #4555 and costs one build per radio: build Meshtastic from source with a userPrefs.jsonc that names our channel, key, region, role, owner names, cadence, plus a one-line patch so the default Bluetooth mode is No PIN. Acceptance on SF and RG, 28 October: after a factory reset each radio was already configured; the snapshot then restored the smart-broadcast minimums (10 s / 20 m), the 21 presets and the original key pair. The ask: approve the flat-battery campaign before the next field test. Fix 2 removes the cause; fix 3 cleans up the past; fix 4 is the hardware-correct answer and the most work.</a:t>
             </a:r>
           </a:p>
         </p:txBody>
@@ -1361,7 +1361,7 @@
           <a:lstStyle/>
           <a:p>
             <a:r>
-              <a:t>Close on the bar. Then the ask: fix 1 is proven on SF; approve the flat-battery campaign that proves it on both radios before the next field test.</a:t>
+              <a:t>Close on the bar. Then the ask: fix 1 is proven on both radios; approve the flat-battery campaign before the next field test.</a:t>
             </a:r>
           </a:p>
         </p:txBody>
@@ -14438,7 +14438,7 @@
                 </a:solidFill>
                 <a:latin typeface="Cambria"/>
               </a:rPr>
-              <a:t>Ranked by leverage; fix 1 is built, flashed and proven on SF</a:t>
+              <a:t>Ranked by leverage; fix 1 is built, flashed and proven on both radios</a:t>
             </a:r>
           </a:p>
         </p:txBody>
@@ -14636,7 +14636,7 @@
                           </a:solidFill>
                           <a:latin typeface="Cambria"/>
                         </a:rPr>
-                        <a:t>SF flashed and accepted Oct 28; RG next</a:t>
+                        <a:t>Both radios flashed and accepted Oct 28</a:t>
                       </a:r>
                     </a:p>
                   </a:txBody>
@@ -15182,7 +15182,7 @@
                 </a:solidFill>
                 <a:latin typeface="Cambria"/>
               </a:rPr>
-              <a:t>PROVEN ON SF, 28 OCTOBER</a:t>
+              <a:t>PROVEN ON BOTH RADIOS, 28 OCTOBER</a:t>
             </a:r>
           </a:p>
           <a:p>
@@ -15198,7 +15198,7 @@
                 </a:solidFill>
                 <a:latin typeface="Cambria"/>
               </a:rPr>
-              <a:t>•  Flashed the fix-1 image, sent meshtastic --factory-reset: the radio came back as SF, Group9 with its 32-byte key, precision 32, No PIN, CLIENT_MUTE, US LONG_FAST, with zero provisioning</a:t>
+              <a:t>•  Flashed each radio's fix-1 image, sent meshtastic --factory-reset: SF came back as SF and RG as RG, Group9 with the 32-byte key, precision 32, No PIN, CLIENT_MUTE, US LONG_FAST, with zero provisioning</a:t>
             </a:r>
           </a:p>
           <a:p>
@@ -17912,7 +17912,7 @@
                 </a:solidFill>
                 <a:latin typeface="Cambria"/>
               </a:rPr>
-              <a:t>makes a future revert restore OUR configuration: proven on SF</a:t>
+              <a:t>makes a future revert restore OUR configuration: proven on both radios</a:t>
             </a:r>
           </a:p>
         </p:txBody>

</xml_diff>

<commit_message>
Full presentation dated 4 November; six-sheet status deck for 28 October (New Mexico rained out, root cause headline, fix 1 on both radios, next steps)
Co-Authored-By: Claude Fable 5.1 <noreply@anthropic.com>
</commit_message>
<xml_diff>
--- a/docs/presentations/Group9_Presentation.pptx
+++ b/docs/presentations/Group9_Presentation.pptx
@@ -6321,7 +6321,7 @@
                 </a:solidFill>
                 <a:latin typeface="Courier New"/>
               </a:rPr>
-              <a:t>SHEET 01/20  REV D  2026-10-28</a:t>
+              <a:t>SHEET 01/20  REV D  2026-11-04</a:t>
             </a:r>
           </a:p>
         </p:txBody>
@@ -6466,7 +6466,7 @@
 Victor Okwonna
 Cannon Thomas
 Sponsor: Dr. Richard Gale
-October 2026</a:t>
+4 November 2026</a:t>
             </a:r>
           </a:p>
         </p:txBody>
@@ -6677,7 +6677,7 @@
                 </a:solidFill>
                 <a:latin typeface="Courier New"/>
               </a:rPr>
-              <a:t>SHEET 10/20  REV D  2026-10-28</a:t>
+              <a:t>SHEET 10/20  REV D  2026-11-04</a:t>
             </a:r>
           </a:p>
         </p:txBody>
@@ -7463,7 +7463,7 @@
                 </a:solidFill>
                 <a:latin typeface="Courier New"/>
               </a:rPr>
-              <a:t>SHEET 11/20  REV D  2026-10-28</a:t>
+              <a:t>SHEET 11/20  REV D  2026-11-04</a:t>
             </a:r>
           </a:p>
         </p:txBody>
@@ -8124,7 +8124,7 @@
                 </a:solidFill>
                 <a:latin typeface="Courier New"/>
               </a:rPr>
-              <a:t>SHEET 12/20  REV D  2026-10-28</a:t>
+              <a:t>SHEET 12/20  REV D  2026-11-04</a:t>
             </a:r>
           </a:p>
         </p:txBody>
@@ -9132,7 +9132,7 @@
                 </a:solidFill>
                 <a:latin typeface="Courier New"/>
               </a:rPr>
-              <a:t>SHEET 13/20  REV D  2026-10-28</a:t>
+              <a:t>SHEET 13/20  REV D  2026-11-04</a:t>
             </a:r>
           </a:p>
         </p:txBody>
@@ -10158,7 +10158,7 @@
                 </a:solidFill>
                 <a:latin typeface="Courier New"/>
               </a:rPr>
-              <a:t>SHEET 14/20  REV D  2026-10-28</a:t>
+              <a:t>SHEET 14/20  REV D  2026-11-04</a:t>
             </a:r>
           </a:p>
         </p:txBody>
@@ -11112,7 +11112,7 @@
                 </a:solidFill>
                 <a:latin typeface="Courier New"/>
               </a:rPr>
-              <a:t>SHEET 15/20  REV D  2026-10-28</a:t>
+              <a:t>SHEET 15/20  REV D  2026-11-04</a:t>
             </a:r>
           </a:p>
         </p:txBody>
@@ -11800,7 +11800,7 @@
                 </a:solidFill>
                 <a:latin typeface="Courier New"/>
               </a:rPr>
-              <a:t>SHEET 16/20  REV D  2026-10-28</a:t>
+              <a:t>SHEET 16/20  REV D  2026-11-04</a:t>
             </a:r>
           </a:p>
         </p:txBody>
@@ -13547,7 +13547,7 @@
                 </a:solidFill>
                 <a:latin typeface="Courier New"/>
               </a:rPr>
-              <a:t>SHEET 17/20  REV D  2026-10-28</a:t>
+              <a:t>SHEET 17/20  REV D  2026-11-04</a:t>
             </a:r>
           </a:p>
         </p:txBody>
@@ -14287,7 +14287,7 @@
                 </a:solidFill>
                 <a:latin typeface="Courier New"/>
               </a:rPr>
-              <a:t>SHEET 18/20  REV D  2026-10-28</a:t>
+              <a:t>SHEET 18/20  REV D  2026-11-04</a:t>
             </a:r>
           </a:p>
         </p:txBody>
@@ -15441,7 +15441,7 @@
                 </a:solidFill>
                 <a:latin typeface="Courier New"/>
               </a:rPr>
-              <a:t>SHEET 19/20  REV D  2026-10-28</a:t>
+              <a:t>SHEET 19/20  REV D  2026-11-04</a:t>
             </a:r>
           </a:p>
         </p:txBody>
@@ -16225,7 +16225,7 @@
                 </a:solidFill>
                 <a:latin typeface="Courier New"/>
               </a:rPr>
-              <a:t>SHEET 02/20  REV D  2026-10-28</a:t>
+              <a:t>SHEET 02/20  REV D  2026-11-04</a:t>
             </a:r>
           </a:p>
         </p:txBody>
@@ -17085,7 +17085,7 @@
                 </a:solidFill>
                 <a:latin typeface="Courier New"/>
               </a:rPr>
-              <a:t>SHEET 20/20  REV D  2026-10-28</a:t>
+              <a:t>SHEET 20/20  REV D  2026-11-04</a:t>
             </a:r>
           </a:p>
         </p:txBody>
@@ -18202,7 +18202,7 @@
                 </a:solidFill>
                 <a:latin typeface="Courier New"/>
               </a:rPr>
-              <a:t>SHEET 03/20  REV D  2026-10-28</a:t>
+              <a:t>SHEET 03/20  REV D  2026-11-04</a:t>
             </a:r>
           </a:p>
         </p:txBody>
@@ -18507,7 +18507,7 @@
                 </a:solidFill>
                 <a:latin typeface="Courier New"/>
               </a:rPr>
-              <a:t>SHEET 04/20  REV D  2026-10-28</a:t>
+              <a:t>SHEET 04/20  REV D  2026-11-04</a:t>
             </a:r>
           </a:p>
         </p:txBody>
@@ -19466,7 +19466,7 @@
                 </a:solidFill>
                 <a:latin typeface="Courier New"/>
               </a:rPr>
-              <a:t>SHEET 05/20  REV D  2026-10-28</a:t>
+              <a:t>SHEET 05/20  REV D  2026-11-04</a:t>
             </a:r>
           </a:p>
         </p:txBody>
@@ -20425,7 +20425,7 @@
                 </a:solidFill>
                 <a:latin typeface="Courier New"/>
               </a:rPr>
-              <a:t>SHEET 06/20  REV D  2026-10-28</a:t>
+              <a:t>SHEET 06/20  REV D  2026-11-04</a:t>
             </a:r>
           </a:p>
         </p:txBody>
@@ -21384,7 +21384,7 @@
                 </a:solidFill>
                 <a:latin typeface="Courier New"/>
               </a:rPr>
-              <a:t>SHEET 07/20  REV D  2026-10-28</a:t>
+              <a:t>SHEET 07/20  REV D  2026-11-04</a:t>
             </a:r>
           </a:p>
         </p:txBody>
@@ -22145,7 +22145,7 @@
                 </a:solidFill>
                 <a:latin typeface="Courier New"/>
               </a:rPr>
-              <a:t>SHEET 08/20  REV D  2026-10-28</a:t>
+              <a:t>SHEET 08/20  REV D  2026-11-04</a:t>
             </a:r>
           </a:p>
         </p:txBody>
@@ -24555,7 +24555,7 @@
                 </a:solidFill>
                 <a:latin typeface="Courier New"/>
               </a:rPr>
-              <a:t>SHEET 09/20  REV D  2026-10-28</a:t>
+              <a:t>SHEET 09/20  REV D  2026-11-04</a:t>
             </a:r>
           </a:p>
         </p:txBody>

</xml_diff>

<commit_message>
New Mexico trip evidence: on site below the Capitan Mountains, NWS flash flood warning; status sheet 2 and full-deck test row updated
Co-Authored-By: Claude Fable 5.1 <noreply@anthropic.com>
</commit_message>
<xml_diff>
--- a/docs/presentations/Group9_Presentation.pptx
+++ b/docs/presentations/Group9_Presentation.pptx
@@ -18296,7 +18296,7 @@
                 </a:solidFill>
                 <a:latin typeface="Courier New"/>
               </a:rPr>
-              <a:t>RED: FAILURES, ROOT-CAUSED.  GREEN: TESTS.  THE HOLLOW TRIANGLE IS NEW MEXICO, RAINED OUT; THAT WEEKEND WENT INTO THE RADIOS INSTEAD.</a:t>
+              <a:t>RED: FAILURES, ROOT-CAUSED.  GREEN: TESTS.  THE HOLLOW TRIANGLE IS NEW MEXICO: ON SITE, STOPPED BY A FLASH FLOOD WARNING; THE WEEKEND WENT INTO THE RADIOS.</a:t>
             </a:r>
           </a:p>
         </p:txBody>
@@ -22977,7 +22977,7 @@
                           </a:solidFill>
                           <a:latin typeface="Cambria"/>
                         </a:rPr>
-                        <a:t>Open highway</a:t>
+                        <a:t>Capitan Mountains, NM</a:t>
                       </a:r>
                     </a:p>
                   </a:txBody>
@@ -22999,7 +22999,7 @@
                           </a:solidFill>
                           <a:latin typeface="Cambria"/>
                         </a:rPr>
-                        <a:t>Rained out; the radios were diagnosed instead (Part II)</a:t>
+                        <a:t>On site; flash flood warning, cancelled; the radios were diagnosed instead (Part II)</a:t>
                       </a:r>
                     </a:p>
                   </a:txBody>

</xml_diff>

<commit_message>
Full deck: new sheet 17, both radios clean two days later; fix status updated; 21 sheets
Co-Authored-By: Claude Fable 5.1 <noreply@anthropic.com>
</commit_message>
<xml_diff>
--- a/docs/presentations/Group9_Presentation.pptx
+++ b/docs/presentations/Group9_Presentation.pptx
@@ -25,6 +25,7 @@
     <p:sldId id="273" r:id="rId25"/>
     <p:sldId id="274" r:id="rId26"/>
     <p:sldId id="275" r:id="rId27"/>
+    <p:sldId id="276" r:id="rId28"/>
   </p:sldIdLst>
   <p:sldSz cx="12191695" cy="6858000" type="screen4x3"/>
   <p:notesSz cx="6858000" cy="9144000"/>
@@ -1081,7 +1082,7 @@
           <a:lstStyle/>
           <a:p>
             <a:r>
-              <a:t>Read the chain left to right in plain words: the battery goes flat; on recovery the radio boots and reboots; every boot writes a settings file with no check of the supply; the supply is sagging in the window where the CPU runs but the flash is not guaranteed; cells are left half-written; next boot a file will not decode and the firmware installs factory defaults and saves them. One link is inferred rather than measured: the rail voltage during the event. An oscilloscope on the 3V3 pin during a transmit burst at 3.4 V cell voltage closes it.</a:t>
+              <a:t>SAY: This is the state today. The red bar is SF as we found it on the 27th; everything after it is zero, including SF after two days at zero percent battery on the new firmware. Be honest about what one cycle proves: the radio was stored flat, not transmitting while it died, so the dangerous write may simply not have happened this time. The five-cycle campaign is what proves the fix.</a:t>
             </a:r>
           </a:p>
         </p:txBody>
@@ -1151,7 +1152,7 @@
           <a:lstStyle/>
           <a:p>
             <a:r>
-              <a:t>Fix 1 is the community's own answer to #4555 and costs one build per radio: build Meshtastic from source with a userPrefs.jsonc that names our channel, key, region, role, owner names, cadence, plus a one-line patch so the default Bluetooth mode is No PIN. Acceptance on SF and RG, 28 October: after a factory reset each radio was already configured; the snapshot then restored the smart-broadcast minimums (10 s / 20 m), the 21 presets and the original key pair. The ask: approve the flat-battery campaign before the next field test. Fix 2 removes the cause; fix 3 cleans up the past; fix 4 is the hardware-correct answer and the most work.</a:t>
+              <a:t>Read the chain left to right in plain words: the battery goes flat; on recovery the radio boots and reboots; every boot writes a settings file with no check of the supply; the supply is sagging in the window where the CPU runs but the flash is not guaranteed; cells are left half-written; next boot a file will not decode and the firmware installs factory defaults and saves them. One link is inferred rather than measured: the rail voltage during the event. An oscilloscope on the 3V3 pin during a transmit burst at 3.4 V cell voltage closes it.</a:t>
             </a:r>
           </a:p>
         </p:txBody>
@@ -1221,7 +1222,7 @@
           <a:lstStyle/>
           <a:p>
             <a:r>
-              <a:t>Attribution policy: say exactly who supplied what. Hypothesis: the recruiter. Experimental design, code and analysis: the AI assistant, under the team's direction. Hardware, authorisation and checking: the team. Reproducibility: the repository. If the audience wants proof, open docs/src/flash_forensics and re-run the sector map on either radio; it takes four minutes.</a:t>
+              <a:t>Fix 1 is the community's own answer to #4555 and costs one build per radio: build Meshtastic from source with a userPrefs.jsonc that names our channel, key, region, role, owner names, cadence, plus a one-line patch so the default Bluetooth mode is No PIN. Acceptance on SF and RG, 28 October: after a factory reset each radio was already configured; the snapshot then restored the smart-broadcast minimums (10 s / 20 m), the 21 presets and the original key pair. The ask: approve the flat-battery campaign before the next field test. Fix 2 removes the cause; fix 3 cleans up the past; fix 4 is the hardware-correct answer and the most work.</a:t>
             </a:r>
           </a:p>
         </p:txBody>
@@ -1317,6 +1318,76 @@
 </file>
 
 <file path=ppt/notesSlides/notesSlide20.xml><?xml version="1.0" encoding="utf-8"?>
+<p:notes xmlns:a="http://schemas.openxmlformats.org/drawingml/2006/main" xmlns:p="http://schemas.openxmlformats.org/presentationml/2006/main" xmlns:r="http://schemas.openxmlformats.org/officeDocument/2006/relationships">
+  <p:cSld>
+    <p:spTree>
+      <p:nvGrpSpPr>
+        <p:cNvPr id="1" name=""/>
+        <p:cNvGrpSpPr/>
+        <p:nvPr/>
+      </p:nvGrpSpPr>
+      <p:grpSpPr>
+        <a:xfrm>
+          <a:off x="0" y="0"/>
+          <a:ext cx="0" cy="0"/>
+          <a:chOff x="0" y="0"/>
+          <a:chExt cx="0" cy="0"/>
+        </a:xfrm>
+      </p:grpSpPr>
+      <p:sp>
+        <p:nvSpPr>
+          <p:cNvPr id="2" name="Slide Image Placeholder 1"/>
+          <p:cNvSpPr>
+            <a:spLocks noGrp="1"/>
+          </p:cNvSpPr>
+          <p:nvPr>
+            <p:ph type="sldImg" idx="2"/>
+          </p:nvPr>
+        </p:nvSpPr>
+        <p:spPr/>
+      </p:sp>
+      <p:sp>
+        <p:nvSpPr>
+          <p:cNvPr id="3" name="Notes Placeholder 2"/>
+          <p:cNvSpPr>
+            <a:spLocks noGrp="1"/>
+          </p:cNvSpPr>
+          <p:nvPr>
+            <p:ph type="body" idx="3" sz="quarter"/>
+          </p:nvPr>
+        </p:nvSpPr>
+        <p:spPr/>
+        <p:txBody>
+          <a:bodyPr/>
+          <a:lstStyle/>
+          <a:p>
+            <a:r>
+              <a:t>Attribution policy: say exactly who supplied what. Hypothesis: the recruiter. Experimental design, code and analysis: the AI assistant, under the team's direction. Hardware, authorisation and checking: the team. Reproducibility: the repository. If the audience wants proof, open docs/src/flash_forensics and re-run the sector map on either radio; it takes four minutes.</a:t>
+            </a:r>
+          </a:p>
+        </p:txBody>
+      </p:sp>
+      <p:sp>
+        <p:nvSpPr>
+          <p:cNvPr id="4" name="Slide Number Placeholder 3"/>
+          <p:cNvSpPr>
+            <a:spLocks noGrp="1"/>
+          </p:cNvSpPr>
+          <p:nvPr>
+            <p:ph type="sldNum" idx="5" sz="quarter"/>
+          </p:nvPr>
+        </p:nvSpPr>
+        <p:spPr/>
+      </p:sp>
+    </p:spTree>
+  </p:cSld>
+  <p:clrMapOvr>
+    <a:masterClrMapping/>
+  </p:clrMapOvr>
+</p:notes>
+</file>
+
+<file path=ppt/notesSlides/notesSlide21.xml><?xml version="1.0" encoding="utf-8"?>
 <p:notes xmlns:a="http://schemas.openxmlformats.org/drawingml/2006/main" xmlns:p="http://schemas.openxmlformats.org/presentationml/2006/main" xmlns:r="http://schemas.openxmlformats.org/officeDocument/2006/relationships">
   <p:cSld>
     <p:spTree>
@@ -6321,7 +6392,7 @@
                 </a:solidFill>
                 <a:latin typeface="Courier New"/>
               </a:rPr>
-              <a:t>SHEET 01/20  REV D  2026-11-04</a:t>
+              <a:t>SHEET 01/21  REV D  2026-11-04</a:t>
             </a:r>
           </a:p>
         </p:txBody>
@@ -6677,7 +6748,7 @@
                 </a:solidFill>
                 <a:latin typeface="Courier New"/>
               </a:rPr>
-              <a:t>SHEET 10/20  REV D  2026-11-04</a:t>
+              <a:t>SHEET 10/21  REV D  2026-11-04</a:t>
             </a:r>
           </a:p>
         </p:txBody>
@@ -7463,7 +7534,7 @@
                 </a:solidFill>
                 <a:latin typeface="Courier New"/>
               </a:rPr>
-              <a:t>SHEET 11/20  REV D  2026-11-04</a:t>
+              <a:t>SHEET 11/21  REV D  2026-11-04</a:t>
             </a:r>
           </a:p>
         </p:txBody>
@@ -8124,7 +8195,7 @@
                 </a:solidFill>
                 <a:latin typeface="Courier New"/>
               </a:rPr>
-              <a:t>SHEET 12/20  REV D  2026-11-04</a:t>
+              <a:t>SHEET 12/21  REV D  2026-11-04</a:t>
             </a:r>
           </a:p>
         </p:txBody>
@@ -9132,7 +9203,7 @@
                 </a:solidFill>
                 <a:latin typeface="Courier New"/>
               </a:rPr>
-              <a:t>SHEET 13/20  REV D  2026-11-04</a:t>
+              <a:t>SHEET 13/21  REV D  2026-11-04</a:t>
             </a:r>
           </a:p>
         </p:txBody>
@@ -10158,7 +10229,7 @@
                 </a:solidFill>
                 <a:latin typeface="Courier New"/>
               </a:rPr>
-              <a:t>SHEET 14/20  REV D  2026-11-04</a:t>
+              <a:t>SHEET 14/21  REV D  2026-11-04</a:t>
             </a:r>
           </a:p>
         </p:txBody>
@@ -10901,7 +10972,7 @@
                 </a:solidFill>
                 <a:latin typeface="Cambria"/>
               </a:rPr>
-              <a:t>Hypothesis: a Qualcomm engineer, October 2026. Experiment design, scripts and analysis drafted with Claude (Anthropic) as an AI assistant; every measurement run by Deo on the team's radios, each step authorised and checked against the raw records (sheet 19).</a:t>
+              <a:t>Hypothesis: a Qualcomm engineer, October 2026. Experiment design, scripts and analysis drafted with Claude (Anthropic) as an AI assistant; every measurement run by Deo on the team's radios, each step authorised and checked against the raw records (sheet 20).</a:t>
             </a:r>
           </a:p>
         </p:txBody>
@@ -11112,7 +11183,7 @@
                 </a:solidFill>
                 <a:latin typeface="Courier New"/>
               </a:rPr>
-              <a:t>SHEET 15/20  REV D  2026-11-04</a:t>
+              <a:t>SHEET 15/21  REV D  2026-11-04</a:t>
             </a:r>
           </a:p>
         </p:txBody>
@@ -11800,7 +11871,7 @@
                 </a:solidFill>
                 <a:latin typeface="Courier New"/>
               </a:rPr>
-              <a:t>SHEET 16/20  REV D  2026-11-04</a:t>
+              <a:t>SHEET 16/21  REV D  2026-11-04</a:t>
             </a:r>
           </a:p>
         </p:txBody>
@@ -13547,7 +13618,617 @@
                 </a:solidFill>
                 <a:latin typeface="Courier New"/>
               </a:rPr>
-              <a:t>SHEET 17/20  REV D  2026-11-04</a:t>
+              <a:t>SHEET 17/21  REV D  2026-11-04</a:t>
+            </a:r>
+          </a:p>
+        </p:txBody>
+      </p:sp>
+      <p:sp>
+        <p:nvSpPr>
+          <p:cNvPr id="7" name="Rectangle 6"/>
+          <p:cNvSpPr/>
+          <p:nvPr/>
+        </p:nvSpPr>
+        <p:spPr>
+          <a:xfrm>
+            <a:off x="9646920" y="347472"/>
+            <a:ext cx="2148840" cy="420624"/>
+          </a:xfrm>
+          <a:prstGeom prst="rect">
+            <a:avLst/>
+          </a:prstGeom>
+          <a:solidFill>
+            <a:srgbClr val="FFFFFF"/>
+          </a:solidFill>
+          <a:ln w="19050">
+            <a:solidFill>
+              <a:srgbClr val="1199BD"/>
+            </a:solidFill>
+          </a:ln>
+          <a:effectLst/>
+        </p:spPr>
+        <p:style>
+          <a:lnRef idx="1">
+            <a:schemeClr val="accent1"/>
+          </a:lnRef>
+          <a:fillRef idx="3">
+            <a:schemeClr val="accent1"/>
+          </a:fillRef>
+          <a:effectRef idx="2">
+            <a:schemeClr val="accent1"/>
+          </a:effectRef>
+          <a:fontRef idx="minor">
+            <a:schemeClr val="lt1"/>
+          </a:fontRef>
+        </p:style>
+        <p:txBody>
+          <a:bodyPr rtlCol="0" anchor="ctr"/>
+          <a:lstStyle/>
+          <a:p>
+            <a:pPr algn="ctr"/>
+          </a:p>
+        </p:txBody>
+      </p:sp>
+      <p:sp>
+        <p:nvSpPr>
+          <p:cNvPr id="8" name="TextBox 7"/>
+          <p:cNvSpPr txBox="1"/>
+          <p:nvPr/>
+        </p:nvSpPr>
+        <p:spPr>
+          <a:xfrm>
+            <a:off x="9646920" y="402336"/>
+            <a:ext cx="2148840" cy="310896"/>
+          </a:xfrm>
+          <a:prstGeom prst="rect">
+            <a:avLst/>
+          </a:prstGeom>
+          <a:noFill/>
+        </p:spPr>
+        <p:txBody>
+          <a:bodyPr wrap="square" lIns="0" rIns="0" tIns="0" bIns="0">
+            <a:spAutoFit/>
+          </a:bodyPr>
+          <a:lstStyle/>
+          <a:p>
+            <a:pPr algn="ctr"/>
+            <a:r>
+              <a:rPr sz="1100" b="1" i="0">
+                <a:solidFill>
+                  <a:srgbClr val="1199BD"/>
+                </a:solidFill>
+                <a:latin typeface="Courier New"/>
+              </a:rPr>
+              <a:t>OWNER: DEO</a:t>
+            </a:r>
+          </a:p>
+        </p:txBody>
+      </p:sp>
+      <p:sp>
+        <p:nvSpPr>
+          <p:cNvPr id="9" name="TextBox 8"/>
+          <p:cNvSpPr txBox="1"/>
+          <p:nvPr/>
+        </p:nvSpPr>
+        <p:spPr>
+          <a:xfrm>
+            <a:off x="457200" y="329184"/>
+            <a:ext cx="9052560" cy="566928"/>
+          </a:xfrm>
+          <a:prstGeom prst="rect">
+            <a:avLst/>
+          </a:prstGeom>
+          <a:noFill/>
+        </p:spPr>
+        <p:txBody>
+          <a:bodyPr wrap="square" lIns="0" rIns="0" tIns="0" bIns="0">
+            <a:spAutoFit/>
+          </a:bodyPr>
+          <a:lstStyle/>
+          <a:p>
+            <a:pPr algn="l"/>
+            <a:r>
+              <a:rPr sz="2300" b="1" i="0" spc="200">
+                <a:solidFill>
+                  <a:srgbClr val="16213D"/>
+                </a:solidFill>
+                <a:latin typeface="Cambria"/>
+              </a:rPr>
+              <a:t>NOW: TWO DAYS LATER, BOTH RADIOS CLEAN</a:t>
+            </a:r>
+          </a:p>
+        </p:txBody>
+      </p:sp>
+      <p:sp>
+        <p:nvSpPr>
+          <p:cNvPr id="10" name="TextBox 9"/>
+          <p:cNvSpPr txBox="1"/>
+          <p:nvPr/>
+        </p:nvSpPr>
+        <p:spPr>
+          <a:xfrm>
+            <a:off x="475488" y="868680"/>
+            <a:ext cx="9052560" cy="320040"/>
+          </a:xfrm>
+          <a:prstGeom prst="rect">
+            <a:avLst/>
+          </a:prstGeom>
+          <a:noFill/>
+        </p:spPr>
+        <p:txBody>
+          <a:bodyPr wrap="square" lIns="0" rIns="0" tIns="0" bIns="0">
+            <a:spAutoFit/>
+          </a:bodyPr>
+          <a:lstStyle/>
+          <a:p>
+            <a:pPr algn="l"/>
+            <a:r>
+              <a:rPr sz="1250" b="0" i="1">
+                <a:solidFill>
+                  <a:srgbClr val="5E6B85"/>
+                </a:solidFill>
+                <a:latin typeface="Cambria"/>
+              </a:rPr>
+              <a:t>Measured again on 29 October, after SF sat two days at 0 percent battery</a:t>
+            </a:r>
+          </a:p>
+        </p:txBody>
+      </p:sp>
+      <p:pic>
+        <p:nvPicPr>
+          <p:cNvPr id="11" name="Picture 10" descr="g_now.png"/>
+          <p:cNvPicPr>
+            <a:picLocks noChangeAspect="1"/>
+          </p:cNvPicPr>
+          <p:nvPr/>
+        </p:nvPicPr>
+        <p:blipFill>
+          <a:blip r:embed="rId2"/>
+          <a:stretch>
+            <a:fillRect/>
+          </a:stretch>
+        </p:blipFill>
+        <p:spPr>
+          <a:xfrm>
+            <a:off x="502920" y="1234440"/>
+            <a:ext cx="11155680" cy="3058815"/>
+          </a:xfrm>
+          <a:prstGeom prst="rect">
+            <a:avLst/>
+          </a:prstGeom>
+        </p:spPr>
+      </p:pic>
+      <p:sp>
+        <p:nvSpPr>
+          <p:cNvPr id="12" name="Rectangle 11"/>
+          <p:cNvSpPr/>
+          <p:nvPr/>
+        </p:nvSpPr>
+        <p:spPr>
+          <a:xfrm>
+            <a:off x="502920" y="4434840"/>
+            <a:ext cx="5486400" cy="1645920"/>
+          </a:xfrm>
+          <a:prstGeom prst="rect">
+            <a:avLst/>
+          </a:prstGeom>
+          <a:solidFill>
+            <a:srgbClr val="F2F5FA"/>
+          </a:solidFill>
+          <a:ln w="15875">
+            <a:solidFill>
+              <a:srgbClr val="1F9D68"/>
+            </a:solidFill>
+          </a:ln>
+          <a:effectLst/>
+        </p:spPr>
+        <p:style>
+          <a:lnRef idx="1">
+            <a:schemeClr val="accent1"/>
+          </a:lnRef>
+          <a:fillRef idx="3">
+            <a:schemeClr val="accent1"/>
+          </a:fillRef>
+          <a:effectRef idx="2">
+            <a:schemeClr val="accent1"/>
+          </a:effectRef>
+          <a:fontRef idx="minor">
+            <a:schemeClr val="lt1"/>
+          </a:fontRef>
+        </p:style>
+        <p:txBody>
+          <a:bodyPr rtlCol="0" anchor="ctr"/>
+          <a:lstStyle/>
+          <a:p>
+            <a:pPr algn="ctr"/>
+          </a:p>
+        </p:txBody>
+      </p:sp>
+      <p:sp>
+        <p:nvSpPr>
+          <p:cNvPr id="13" name="TextBox 12"/>
+          <p:cNvSpPr txBox="1"/>
+          <p:nvPr/>
+        </p:nvSpPr>
+        <p:spPr>
+          <a:xfrm>
+            <a:off x="667512" y="4553712"/>
+            <a:ext cx="5157216" cy="1408176"/>
+          </a:xfrm>
+          <a:prstGeom prst="rect">
+            <a:avLst/>
+          </a:prstGeom>
+          <a:noFill/>
+        </p:spPr>
+        <p:txBody>
+          <a:bodyPr wrap="square" lIns="0" rIns="0" tIns="0" bIns="0">
+            <a:spAutoFit/>
+          </a:bodyPr>
+          <a:lstStyle/>
+          <a:p>
+            <a:r>
+              <a:rPr sz="1250" b="1" spc="100">
+                <a:solidFill>
+                  <a:srgbClr val="1F9D68"/>
+                </a:solidFill>
+                <a:latin typeface="Cambria"/>
+              </a:rPr>
+              <a:t>WHAT WAS CHECKED ON 29 OCTOBER</a:t>
+            </a:r>
+          </a:p>
+          <a:p>
+            <a:pPr>
+              <a:spcBef>
+                <a:spcPts val="400"/>
+              </a:spcBef>
+            </a:pPr>
+            <a:r>
+              <a:rPr sz="1100">
+                <a:solidFill>
+                  <a:srgbClr val="222A3F"/>
+                </a:solidFill>
+                <a:latin typeface="Cambria"/>
+              </a:rPr>
+              <a:t>•  Configuration read back with zero provisioning on both radios: name, role, No PIN, Group9 with key, precision 32, cadence, presets: all intact</a:t>
+            </a:r>
+          </a:p>
+          <a:p>
+            <a:pPr>
+              <a:spcBef>
+                <a:spcPts val="400"/>
+              </a:spcBef>
+            </a:pPr>
+            <a:r>
+              <a:rPr sz="1100">
+                <a:solidFill>
+                  <a:srgbClr val="222A3F"/>
+                </a:solidFill>
+                <a:latin typeface="Cambria"/>
+              </a:rPr>
+              <a:t>•  Flash settings area read three times each: 0 differing bytes, 0 unstable sectors on SF and on RG</a:t>
+            </a:r>
+          </a:p>
+        </p:txBody>
+      </p:sp>
+      <p:sp>
+        <p:nvSpPr>
+          <p:cNvPr id="14" name="Rectangle 13"/>
+          <p:cNvSpPr/>
+          <p:nvPr/>
+        </p:nvSpPr>
+        <p:spPr>
+          <a:xfrm>
+            <a:off x="6172200" y="4434840"/>
+            <a:ext cx="5532120" cy="1645920"/>
+          </a:xfrm>
+          <a:prstGeom prst="rect">
+            <a:avLst/>
+          </a:prstGeom>
+          <a:solidFill>
+            <a:srgbClr val="F2F5FA"/>
+          </a:solidFill>
+          <a:ln w="15875">
+            <a:solidFill>
+              <a:srgbClr val="E58E1A"/>
+            </a:solidFill>
+          </a:ln>
+          <a:effectLst/>
+        </p:spPr>
+        <p:style>
+          <a:lnRef idx="1">
+            <a:schemeClr val="accent1"/>
+          </a:lnRef>
+          <a:fillRef idx="3">
+            <a:schemeClr val="accent1"/>
+          </a:fillRef>
+          <a:effectRef idx="2">
+            <a:schemeClr val="accent1"/>
+          </a:effectRef>
+          <a:fontRef idx="minor">
+            <a:schemeClr val="lt1"/>
+          </a:fontRef>
+        </p:style>
+        <p:txBody>
+          <a:bodyPr rtlCol="0" anchor="ctr"/>
+          <a:lstStyle/>
+          <a:p>
+            <a:pPr algn="ctr"/>
+          </a:p>
+        </p:txBody>
+      </p:sp>
+      <p:sp>
+        <p:nvSpPr>
+          <p:cNvPr id="15" name="TextBox 14"/>
+          <p:cNvSpPr txBox="1"/>
+          <p:nvPr/>
+        </p:nvSpPr>
+        <p:spPr>
+          <a:xfrm>
+            <a:off x="6336792" y="4553712"/>
+            <a:ext cx="5202936" cy="1408176"/>
+          </a:xfrm>
+          <a:prstGeom prst="rect">
+            <a:avLst/>
+          </a:prstGeom>
+          <a:noFill/>
+        </p:spPr>
+        <p:txBody>
+          <a:bodyPr wrap="square" lIns="0" rIns="0" tIns="0" bIns="0">
+            <a:spAutoFit/>
+          </a:bodyPr>
+          <a:lstStyle/>
+          <a:p>
+            <a:r>
+              <a:rPr sz="1250" b="1" spc="100">
+                <a:solidFill>
+                  <a:srgbClr val="E58E1A"/>
+                </a:solidFill>
+                <a:latin typeface="Cambria"/>
+              </a:rPr>
+              <a:t>READ IT HONESTLY</a:t>
+            </a:r>
+          </a:p>
+          <a:p>
+            <a:pPr>
+              <a:spcBef>
+                <a:spcPts val="400"/>
+              </a:spcBef>
+            </a:pPr>
+            <a:r>
+              <a:rPr sz="1100">
+                <a:solidFill>
+                  <a:srgbClr val="222A3F"/>
+                </a:solidFill>
+                <a:latin typeface="Cambria"/>
+              </a:rPr>
+              <a:t>•  SF's flat-battery episode is the exact condition that wiped it three times before; this time nothing was lost and the flash stayed clean</a:t>
+            </a:r>
+          </a:p>
+          <a:p>
+            <a:pPr>
+              <a:spcBef>
+                <a:spcPts val="400"/>
+              </a:spcBef>
+            </a:pPr>
+            <a:r>
+              <a:rPr sz="1100">
+                <a:solidFill>
+                  <a:srgbClr val="222A3F"/>
+                </a:solidFill>
+                <a:latin typeface="Cambria"/>
+              </a:rPr>
+              <a:t>•  One cycle is evidence, not proof: the radio was stored flat, not transmitting while it died. The campaign of five running-flat cycles per radio is what closes it</a:t>
+            </a:r>
+          </a:p>
+        </p:txBody>
+      </p:sp>
+    </p:spTree>
+  </p:cSld>
+  <p:clrMapOvr>
+    <a:masterClrMapping/>
+  </p:clrMapOvr>
+</p:sld>
+</file>
+
+<file path=ppt/slides/slide18.xml><?xml version="1.0" encoding="utf-8"?>
+<p:sld xmlns:a="http://schemas.openxmlformats.org/drawingml/2006/main" xmlns:p="http://schemas.openxmlformats.org/presentationml/2006/main" xmlns:r="http://schemas.openxmlformats.org/officeDocument/2006/relationships">
+  <p:cSld>
+    <p:spTree>
+      <p:nvGrpSpPr>
+        <p:cNvPr id="1" name=""/>
+        <p:cNvGrpSpPr/>
+        <p:nvPr/>
+      </p:nvGrpSpPr>
+      <p:grpSpPr/>
+      <p:sp>
+        <p:nvSpPr>
+          <p:cNvPr id="2" name="Rectangle 1"/>
+          <p:cNvSpPr/>
+          <p:nvPr/>
+        </p:nvSpPr>
+        <p:spPr>
+          <a:xfrm>
+            <a:off x="164592" y="146304"/>
+            <a:ext cx="11859768" cy="6565392"/>
+          </a:xfrm>
+          <a:prstGeom prst="rect">
+            <a:avLst/>
+          </a:prstGeom>
+          <a:noFill/>
+          <a:ln w="22225">
+            <a:solidFill>
+              <a:srgbClr val="16213D"/>
+            </a:solidFill>
+          </a:ln>
+          <a:effectLst/>
+        </p:spPr>
+        <p:style>
+          <a:lnRef idx="1">
+            <a:schemeClr val="accent1"/>
+          </a:lnRef>
+          <a:fillRef idx="3">
+            <a:schemeClr val="accent1"/>
+          </a:fillRef>
+          <a:effectRef idx="2">
+            <a:schemeClr val="accent1"/>
+          </a:effectRef>
+          <a:fontRef idx="minor">
+            <a:schemeClr val="lt1"/>
+          </a:fontRef>
+        </p:style>
+        <p:txBody>
+          <a:bodyPr rtlCol="0" anchor="ctr"/>
+          <a:lstStyle/>
+          <a:p>
+            <a:pPr algn="ctr"/>
+          </a:p>
+        </p:txBody>
+      </p:sp>
+      <p:sp>
+        <p:nvSpPr>
+          <p:cNvPr id="3" name="Rectangle 2"/>
+          <p:cNvSpPr/>
+          <p:nvPr/>
+        </p:nvSpPr>
+        <p:spPr>
+          <a:xfrm>
+            <a:off x="164592" y="6272784"/>
+            <a:ext cx="11859768" cy="12700"/>
+          </a:xfrm>
+          <a:prstGeom prst="rect">
+            <a:avLst/>
+          </a:prstGeom>
+          <a:solidFill>
+            <a:srgbClr val="16213D"/>
+          </a:solidFill>
+          <a:ln>
+            <a:noFill/>
+          </a:ln>
+          <a:effectLst/>
+        </p:spPr>
+        <p:style>
+          <a:lnRef idx="1">
+            <a:schemeClr val="accent1"/>
+          </a:lnRef>
+          <a:fillRef idx="3">
+            <a:schemeClr val="accent1"/>
+          </a:fillRef>
+          <a:effectRef idx="2">
+            <a:schemeClr val="accent1"/>
+          </a:effectRef>
+          <a:fontRef idx="minor">
+            <a:schemeClr val="lt1"/>
+          </a:fontRef>
+        </p:style>
+        <p:txBody>
+          <a:bodyPr rtlCol="0" anchor="ctr"/>
+          <a:lstStyle/>
+          <a:p>
+            <a:pPr algn="ctr"/>
+          </a:p>
+        </p:txBody>
+      </p:sp>
+      <p:sp>
+        <p:nvSpPr>
+          <p:cNvPr id="4" name="TextBox 3"/>
+          <p:cNvSpPr txBox="1"/>
+          <p:nvPr/>
+        </p:nvSpPr>
+        <p:spPr>
+          <a:xfrm>
+            <a:off x="320040" y="6345936"/>
+            <a:ext cx="4206240" cy="292608"/>
+          </a:xfrm>
+          <a:prstGeom prst="rect">
+            <a:avLst/>
+          </a:prstGeom>
+          <a:noFill/>
+        </p:spPr>
+        <p:txBody>
+          <a:bodyPr wrap="square" lIns="0" rIns="0" tIns="0" bIns="0">
+            <a:spAutoFit/>
+          </a:bodyPr>
+          <a:lstStyle/>
+          <a:p>
+            <a:pPr algn="l"/>
+            <a:r>
+              <a:rPr sz="900" b="0" i="0">
+                <a:solidFill>
+                  <a:srgbClr val="5E6B85"/>
+                </a:solidFill>
+                <a:latin typeface="Courier New"/>
+              </a:rPr>
+              <a:t>GROUP 9  |  OFF-GRID VEHICLE TRACKER</a:t>
+            </a:r>
+          </a:p>
+        </p:txBody>
+      </p:sp>
+      <p:sp>
+        <p:nvSpPr>
+          <p:cNvPr id="5" name="TextBox 4"/>
+          <p:cNvSpPr txBox="1"/>
+          <p:nvPr/>
+        </p:nvSpPr>
+        <p:spPr>
+          <a:xfrm>
+            <a:off x="4572000" y="6345936"/>
+            <a:ext cx="4206240" cy="292608"/>
+          </a:xfrm>
+          <a:prstGeom prst="rect">
+            <a:avLst/>
+          </a:prstGeom>
+          <a:noFill/>
+        </p:spPr>
+        <p:txBody>
+          <a:bodyPr wrap="square" lIns="0" rIns="0" tIns="0" bIns="0">
+            <a:spAutoFit/>
+          </a:bodyPr>
+          <a:lstStyle/>
+          <a:p>
+            <a:pPr algn="ctr"/>
+            <a:r>
+              <a:rPr sz="900" b="0" i="0">
+                <a:solidFill>
+                  <a:srgbClr val="5E6B85"/>
+                </a:solidFill>
+                <a:latin typeface="Courier New"/>
+              </a:rPr>
+              <a:t>PART II - ROOT CAUSE</a:t>
+            </a:r>
+          </a:p>
+        </p:txBody>
+      </p:sp>
+      <p:sp>
+        <p:nvSpPr>
+          <p:cNvPr id="6" name="TextBox 5"/>
+          <p:cNvSpPr txBox="1"/>
+          <p:nvPr/>
+        </p:nvSpPr>
+        <p:spPr>
+          <a:xfrm>
+            <a:off x="8869680" y="6345936"/>
+            <a:ext cx="3017520" cy="292608"/>
+          </a:xfrm>
+          <a:prstGeom prst="rect">
+            <a:avLst/>
+          </a:prstGeom>
+          <a:noFill/>
+        </p:spPr>
+        <p:txBody>
+          <a:bodyPr wrap="square" lIns="0" rIns="0" tIns="0" bIns="0">
+            <a:spAutoFit/>
+          </a:bodyPr>
+          <a:lstStyle/>
+          <a:p>
+            <a:pPr algn="r"/>
+            <a:r>
+              <a:rPr sz="900" b="0" i="0">
+                <a:solidFill>
+                  <a:srgbClr val="5E6B85"/>
+                </a:solidFill>
+                <a:latin typeface="Courier New"/>
+              </a:rPr>
+              <a:t>SHEET 18/21  REV D  2026-11-04</a:t>
             </a:r>
           </a:p>
         </p:txBody>
@@ -14089,7 +14770,7 @@
 </p:sld>
 </file>
 
-<file path=ppt/slides/slide18.xml><?xml version="1.0" encoding="utf-8"?>
+<file path=ppt/slides/slide19.xml><?xml version="1.0" encoding="utf-8"?>
 <p:sld xmlns:a="http://schemas.openxmlformats.org/drawingml/2006/main" xmlns:p="http://schemas.openxmlformats.org/presentationml/2006/main" xmlns:r="http://schemas.openxmlformats.org/officeDocument/2006/relationships">
   <p:cSld>
     <p:spTree>
@@ -14287,7 +14968,7 @@
                 </a:solidFill>
                 <a:latin typeface="Courier New"/>
               </a:rPr>
-              <a:t>SHEET 18/20  REV D  2026-11-04</a:t>
+              <a:t>SHEET 19/21  REV D  2026-11-04</a:t>
             </a:r>
           </a:p>
         </p:txBody>
@@ -14636,7 +15317,7 @@
                           </a:solidFill>
                           <a:latin typeface="Cambria"/>
                         </a:rPr>
-                        <a:t>Both radios flashed and accepted Oct 28</a:t>
+                        <a:t>Both radios flashed and accepted Oct 28; SF clean after 2 days at 0 percent, Oct 29</a:t>
                       </a:r>
                     </a:p>
                   </a:txBody>
@@ -15243,7 +15924,7 @@
 </p:sld>
 </file>
 
-<file path=ppt/slides/slide19.xml><?xml version="1.0" encoding="utf-8"?>
+<file path=ppt/slides/slide2.xml><?xml version="1.0" encoding="utf-8"?>
 <p:sld xmlns:a="http://schemas.openxmlformats.org/drawingml/2006/main" xmlns:p="http://schemas.openxmlformats.org/presentationml/2006/main" xmlns:r="http://schemas.openxmlformats.org/officeDocument/2006/relationships">
   <p:cSld>
     <p:spTree>
@@ -15406,7 +16087,7 @@
                 </a:solidFill>
                 <a:latin typeface="Courier New"/>
               </a:rPr>
-              <a:t>PART II - ROOT CAUSE</a:t>
+              <a:t>PART I - THE FAILURES</a:t>
             </a:r>
           </a:p>
         </p:txBody>
@@ -15441,7 +16122,867 @@
                 </a:solidFill>
                 <a:latin typeface="Courier New"/>
               </a:rPr>
-              <a:t>SHEET 19/20  REV D  2026-11-04</a:t>
+              <a:t>SHEET 02/21  REV D  2026-11-04</a:t>
+            </a:r>
+          </a:p>
+        </p:txBody>
+      </p:sp>
+      <p:sp>
+        <p:nvSpPr>
+          <p:cNvPr id="7" name="TextBox 6"/>
+          <p:cNvSpPr txBox="1"/>
+          <p:nvPr/>
+        </p:nvSpPr>
+        <p:spPr>
+          <a:xfrm>
+            <a:off x="457200" y="329184"/>
+            <a:ext cx="9052560" cy="566928"/>
+          </a:xfrm>
+          <a:prstGeom prst="rect">
+            <a:avLst/>
+          </a:prstGeom>
+          <a:noFill/>
+        </p:spPr>
+        <p:txBody>
+          <a:bodyPr wrap="square" lIns="0" rIns="0" tIns="0" bIns="0">
+            <a:spAutoFit/>
+          </a:bodyPr>
+          <a:lstStyle/>
+          <a:p>
+            <a:pPr algn="l"/>
+            <a:r>
+              <a:rPr sz="2300" b="1" i="0" spc="200">
+                <a:solidFill>
+                  <a:srgbClr val="16213D"/>
+                </a:solidFill>
+                <a:latin typeface="Cambria"/>
+              </a:rPr>
+              <a:t>WHY THE FAILURES ARE THE DELIVERABLE</a:t>
+            </a:r>
+          </a:p>
+        </p:txBody>
+      </p:sp>
+      <p:sp>
+        <p:nvSpPr>
+          <p:cNvPr id="8" name="Rectangle 7"/>
+          <p:cNvSpPr/>
+          <p:nvPr/>
+        </p:nvSpPr>
+        <p:spPr>
+          <a:xfrm>
+            <a:off x="502920" y="1234440"/>
+            <a:ext cx="5394960" cy="1481328"/>
+          </a:xfrm>
+          <a:prstGeom prst="rect">
+            <a:avLst/>
+          </a:prstGeom>
+          <a:solidFill>
+            <a:srgbClr val="F2F5FA"/>
+          </a:solidFill>
+          <a:ln w="15875">
+            <a:solidFill>
+              <a:srgbClr val="16213D"/>
+            </a:solidFill>
+          </a:ln>
+          <a:effectLst/>
+        </p:spPr>
+        <p:style>
+          <a:lnRef idx="1">
+            <a:schemeClr val="accent1"/>
+          </a:lnRef>
+          <a:fillRef idx="3">
+            <a:schemeClr val="accent1"/>
+          </a:fillRef>
+          <a:effectRef idx="2">
+            <a:schemeClr val="accent1"/>
+          </a:effectRef>
+          <a:fontRef idx="minor">
+            <a:schemeClr val="lt1"/>
+          </a:fontRef>
+        </p:style>
+        <p:txBody>
+          <a:bodyPr rtlCol="0" anchor="ctr"/>
+          <a:lstStyle/>
+          <a:p>
+            <a:pPr algn="ctr"/>
+          </a:p>
+        </p:txBody>
+      </p:sp>
+      <p:sp>
+        <p:nvSpPr>
+          <p:cNvPr id="9" name="TextBox 8"/>
+          <p:cNvSpPr txBox="1"/>
+          <p:nvPr/>
+        </p:nvSpPr>
+        <p:spPr>
+          <a:xfrm>
+            <a:off x="667512" y="1353312"/>
+            <a:ext cx="5065776" cy="1243584"/>
+          </a:xfrm>
+          <a:prstGeom prst="rect">
+            <a:avLst/>
+          </a:prstGeom>
+          <a:noFill/>
+        </p:spPr>
+        <p:txBody>
+          <a:bodyPr wrap="square" lIns="0" rIns="0" tIns="0" bIns="0">
+            <a:spAutoFit/>
+          </a:bodyPr>
+          <a:lstStyle/>
+          <a:p>
+            <a:r>
+              <a:rPr sz="1300" b="1" spc="100">
+                <a:solidFill>
+                  <a:srgbClr val="16213D"/>
+                </a:solidFill>
+                <a:latin typeface="Cambria"/>
+              </a:rPr>
+              <a:t>A FAILURE IS ONLY USEFUL ONCE IT HAS A SIGNATURE</a:t>
+            </a:r>
+          </a:p>
+          <a:p>
+            <a:pPr>
+              <a:spcBef>
+                <a:spcPts val="400"/>
+              </a:spcBef>
+            </a:pPr>
+            <a:r>
+              <a:rPr sz="1200">
+                <a:solidFill>
+                  <a:srgbClr val="222A3F"/>
+                </a:solidFill>
+                <a:latin typeface="Cambria"/>
+              </a:rPr>
+              <a:t>Each catalog entry records the symptom exactly as it appears, the root cause, and the recovery, so the next person recognizes it in minutes, not days.</a:t>
+            </a:r>
+          </a:p>
+        </p:txBody>
+      </p:sp>
+      <p:sp>
+        <p:nvSpPr>
+          <p:cNvPr id="10" name="Rectangle 9"/>
+          <p:cNvSpPr/>
+          <p:nvPr/>
+        </p:nvSpPr>
+        <p:spPr>
+          <a:xfrm>
+            <a:off x="502920" y="2834640"/>
+            <a:ext cx="5394960" cy="1481328"/>
+          </a:xfrm>
+          <a:prstGeom prst="rect">
+            <a:avLst/>
+          </a:prstGeom>
+          <a:solidFill>
+            <a:srgbClr val="F2F5FA"/>
+          </a:solidFill>
+          <a:ln w="15875">
+            <a:solidFill>
+              <a:srgbClr val="16213D"/>
+            </a:solidFill>
+          </a:ln>
+          <a:effectLst/>
+        </p:spPr>
+        <p:style>
+          <a:lnRef idx="1">
+            <a:schemeClr val="accent1"/>
+          </a:lnRef>
+          <a:fillRef idx="3">
+            <a:schemeClr val="accent1"/>
+          </a:fillRef>
+          <a:effectRef idx="2">
+            <a:schemeClr val="accent1"/>
+          </a:effectRef>
+          <a:fontRef idx="minor">
+            <a:schemeClr val="lt1"/>
+          </a:fontRef>
+        </p:style>
+        <p:txBody>
+          <a:bodyPr rtlCol="0" anchor="ctr"/>
+          <a:lstStyle/>
+          <a:p>
+            <a:pPr algn="ctr"/>
+          </a:p>
+        </p:txBody>
+      </p:sp>
+      <p:sp>
+        <p:nvSpPr>
+          <p:cNvPr id="11" name="TextBox 10"/>
+          <p:cNvSpPr txBox="1"/>
+          <p:nvPr/>
+        </p:nvSpPr>
+        <p:spPr>
+          <a:xfrm>
+            <a:off x="667512" y="2953512"/>
+            <a:ext cx="5065776" cy="1243584"/>
+          </a:xfrm>
+          <a:prstGeom prst="rect">
+            <a:avLst/>
+          </a:prstGeom>
+          <a:noFill/>
+        </p:spPr>
+        <p:txBody>
+          <a:bodyPr wrap="square" lIns="0" rIns="0" tIns="0" bIns="0">
+            <a:spAutoFit/>
+          </a:bodyPr>
+          <a:lstStyle/>
+          <a:p>
+            <a:r>
+              <a:rPr sz="1300" b="1" spc="100">
+                <a:solidFill>
+                  <a:srgbClr val="16213D"/>
+                </a:solidFill>
+                <a:latin typeface="Cambria"/>
+              </a:rPr>
+              <a:t>EACH FAILURE PRODUCED A RULE OR A FEATURE</a:t>
+            </a:r>
+          </a:p>
+          <a:p>
+            <a:pPr>
+              <a:spcBef>
+                <a:spcPts val="400"/>
+              </a:spcBef>
+            </a:pPr>
+            <a:r>
+              <a:rPr sz="1200">
+                <a:solidFill>
+                  <a:srgbClr val="222A3F"/>
+                </a:solidFill>
+                <a:latin typeface="Cambria"/>
+              </a:rPr>
+              <a:t>Pre-flight checks, cadence-aware alarms, the course-up compass, the config snapshot, the LINK LOST alarm: none were in the plan. All came from something breaking.</a:t>
+            </a:r>
+          </a:p>
+        </p:txBody>
+      </p:sp>
+      <p:sp>
+        <p:nvSpPr>
+          <p:cNvPr id="12" name="Rectangle 11"/>
+          <p:cNvSpPr/>
+          <p:nvPr/>
+        </p:nvSpPr>
+        <p:spPr>
+          <a:xfrm>
+            <a:off x="502920" y="4434840"/>
+            <a:ext cx="5394960" cy="1481328"/>
+          </a:xfrm>
+          <a:prstGeom prst="rect">
+            <a:avLst/>
+          </a:prstGeom>
+          <a:solidFill>
+            <a:srgbClr val="F2F5FA"/>
+          </a:solidFill>
+          <a:ln w="15875">
+            <a:solidFill>
+              <a:srgbClr val="16213D"/>
+            </a:solidFill>
+          </a:ln>
+          <a:effectLst/>
+        </p:spPr>
+        <p:style>
+          <a:lnRef idx="1">
+            <a:schemeClr val="accent1"/>
+          </a:lnRef>
+          <a:fillRef idx="3">
+            <a:schemeClr val="accent1"/>
+          </a:fillRef>
+          <a:effectRef idx="2">
+            <a:schemeClr val="accent1"/>
+          </a:effectRef>
+          <a:fontRef idx="minor">
+            <a:schemeClr val="lt1"/>
+          </a:fontRef>
+        </p:style>
+        <p:txBody>
+          <a:bodyPr rtlCol="0" anchor="ctr"/>
+          <a:lstStyle/>
+          <a:p>
+            <a:pPr algn="ctr"/>
+          </a:p>
+        </p:txBody>
+      </p:sp>
+      <p:sp>
+        <p:nvSpPr>
+          <p:cNvPr id="13" name="TextBox 12"/>
+          <p:cNvSpPr txBox="1"/>
+          <p:nvPr/>
+        </p:nvSpPr>
+        <p:spPr>
+          <a:xfrm>
+            <a:off x="667512" y="4553712"/>
+            <a:ext cx="5065776" cy="1243584"/>
+          </a:xfrm>
+          <a:prstGeom prst="rect">
+            <a:avLst/>
+          </a:prstGeom>
+          <a:noFill/>
+        </p:spPr>
+        <p:txBody>
+          <a:bodyPr wrap="square" lIns="0" rIns="0" tIns="0" bIns="0">
+            <a:spAutoFit/>
+          </a:bodyPr>
+          <a:lstStyle/>
+          <a:p>
+            <a:r>
+              <a:rPr sz="1300" b="1" spc="100">
+                <a:solidFill>
+                  <a:srgbClr val="16213D"/>
+                </a:solidFill>
+                <a:latin typeface="Cambria"/>
+              </a:rPr>
+              <a:t>FIELD EQUIPMENT FAILS BETWEEN OUTINGS</a:t>
+            </a:r>
+          </a:p>
+          <a:p>
+            <a:pPr>
+              <a:spcBef>
+                <a:spcPts val="400"/>
+              </a:spcBef>
+            </a:pPr>
+            <a:r>
+              <a:rPr sz="1200">
+                <a:solidFill>
+                  <a:srgbClr val="222A3F"/>
+                </a:solidFill>
+                <a:latin typeface="Cambria"/>
+              </a:rPr>
+              <a:t>Three of ten failures struck the night before a test. Every one was cleared in time because its signature had already been written down.</a:t>
+            </a:r>
+          </a:p>
+        </p:txBody>
+      </p:sp>
+      <p:sp>
+        <p:nvSpPr>
+          <p:cNvPr id="14" name="TextBox 13"/>
+          <p:cNvSpPr txBox="1"/>
+          <p:nvPr/>
+        </p:nvSpPr>
+        <p:spPr>
+          <a:xfrm>
+            <a:off x="6126480" y="1234440"/>
+            <a:ext cx="5577840" cy="274320"/>
+          </a:xfrm>
+          <a:prstGeom prst="rect">
+            <a:avLst/>
+          </a:prstGeom>
+          <a:noFill/>
+        </p:spPr>
+        <p:txBody>
+          <a:bodyPr wrap="square" lIns="0" rIns="0" tIns="0" bIns="0">
+            <a:spAutoFit/>
+          </a:bodyPr>
+          <a:lstStyle/>
+          <a:p>
+            <a:pPr algn="l"/>
+            <a:r>
+              <a:rPr sz="1100" b="1" i="0">
+                <a:solidFill>
+                  <a:srgbClr val="E58E1A"/>
+                </a:solidFill>
+                <a:latin typeface="Courier New"/>
+              </a:rPr>
+              <a:t>WHAT ONE CATALOG ENTRY LOOKS LIKE</a:t>
+            </a:r>
+          </a:p>
+        </p:txBody>
+      </p:sp>
+      <p:graphicFrame>
+        <p:nvGraphicFramePr>
+          <p:cNvPr id="15" name="Table 14"/>
+          <p:cNvGraphicFramePr>
+            <a:graphicFrameLocks noGrp="1"/>
+          </p:cNvGraphicFramePr>
+          <p:nvPr/>
+        </p:nvGraphicFramePr>
+        <p:xfrm>
+          <a:off x="6126480" y="1554480"/>
+          <a:ext cx="5577840" cy="3566160"/>
+        </p:xfrm>
+        <a:graphic>
+          <a:graphicData uri="http://schemas.openxmlformats.org/drawingml/2006/table">
+            <a:tbl>
+              <a:tblPr firstRow="1" bandRow="1">
+                <a:tableStyleId>{5C22544A-7EE6-4342-B048-85BDC9FD1C3A}</a:tableStyleId>
+              </a:tblPr>
+              <a:tblGrid>
+                <a:gridCol w="1143000"/>
+                <a:gridCol w="4434840"/>
+              </a:tblGrid>
+              <a:tr h="713232">
+                <a:tc>
+                  <a:txBody>
+                    <a:bodyPr/>
+                    <a:lstStyle/>
+                    <a:p>
+                      <a:r>
+                        <a:rPr sz="1050" b="1">
+                          <a:solidFill>
+                            <a:srgbClr val="FFFFFF"/>
+                          </a:solidFill>
+                          <a:latin typeface="Cambria"/>
+                        </a:rPr>
+                        <a:t>Field</a:t>
+                      </a:r>
+                    </a:p>
+                  </a:txBody>
+                  <a:tcPr marL="73152" marR="73152" marT="27432" marB="27432">
+                    <a:solidFill>
+                      <a:srgbClr val="16213D"/>
+                    </a:solidFill>
+                  </a:tcPr>
+                </a:tc>
+                <a:tc>
+                  <a:txBody>
+                    <a:bodyPr/>
+                    <a:lstStyle/>
+                    <a:p>
+                      <a:r>
+                        <a:rPr sz="1050" b="1">
+                          <a:solidFill>
+                            <a:srgbClr val="FFFFFF"/>
+                          </a:solidFill>
+                          <a:latin typeface="Cambria"/>
+                        </a:rPr>
+                        <a:t>Entry 1, Technical Manual Section 16</a:t>
+                      </a:r>
+                    </a:p>
+                  </a:txBody>
+                  <a:tcPr marL="73152" marR="73152" marT="27432" marB="27432">
+                    <a:solidFill>
+                      <a:srgbClr val="16213D"/>
+                    </a:solidFill>
+                  </a:tcPr>
+                </a:tc>
+              </a:tr>
+              <a:tr h="713232">
+                <a:tc>
+                  <a:txBody>
+                    <a:bodyPr/>
+                    <a:lstStyle/>
+                    <a:p>
+                      <a:r>
+                        <a:rPr sz="1050" b="1">
+                          <a:solidFill>
+                            <a:srgbClr val="222A3F"/>
+                          </a:solidFill>
+                          <a:latin typeface="Cambria"/>
+                        </a:rPr>
+                        <a:t>Symptom</a:t>
+                      </a:r>
+                    </a:p>
+                  </a:txBody>
+                  <a:tcPr marL="73152" marR="73152" marT="27432" marB="27432">
+                    <a:solidFill>
+                      <a:srgbClr val="F2F5FA"/>
+                    </a:solidFill>
+                  </a:tcPr>
+                </a:tc>
+                <a:tc>
+                  <a:txBody>
+                    <a:bodyPr/>
+                    <a:lstStyle/>
+                    <a:p>
+                      <a:r>
+                        <a:rPr sz="1050" b="0">
+                          <a:solidFill>
+                            <a:srgbClr val="222A3F"/>
+                          </a:solidFill>
+                          <a:latin typeface="Cambria"/>
+                        </a:rPr>
+                        <a:t>Total mutual silence; configs read back identical; 0 percent channel utilization</a:t>
+                      </a:r>
+                    </a:p>
+                  </a:txBody>
+                  <a:tcPr marL="73152" marR="73152" marT="27432" marB="27432">
+                    <a:solidFill>
+                      <a:srgbClr val="F2F5FA"/>
+                    </a:solidFill>
+                  </a:tcPr>
+                </a:tc>
+              </a:tr>
+              <a:tr h="713232">
+                <a:tc>
+                  <a:txBody>
+                    <a:bodyPr/>
+                    <a:lstStyle/>
+                    <a:p>
+                      <a:r>
+                        <a:rPr sz="1050" b="1">
+                          <a:solidFill>
+                            <a:srgbClr val="222A3F"/>
+                          </a:solidFill>
+                          <a:latin typeface="Cambria"/>
+                        </a:rPr>
+                        <a:t>Root cause</a:t>
+                      </a:r>
+                    </a:p>
+                  </a:txBody>
+                  <a:tcPr marL="73152" marR="73152" marT="27432" marB="27432">
+                    <a:solidFill>
+                      <a:srgbClr val="FFFFFF"/>
+                    </a:solidFill>
+                  </a:tcPr>
+                </a:tc>
+                <a:tc>
+                  <a:txBody>
+                    <a:bodyPr/>
+                    <a:lstStyle/>
+                    <a:p>
+                      <a:r>
+                        <a:rPr sz="1050" b="0">
+                          <a:solidFill>
+                            <a:srgbClr val="222A3F"/>
+                          </a:solidFill>
+                          <a:latin typeface="Cambria"/>
+                        </a:rPr>
+                        <a:t>Frequency-slot mismatch: a channel write silently reverted, leaving the radios on different slots with the same key</a:t>
+                      </a:r>
+                    </a:p>
+                  </a:txBody>
+                  <a:tcPr marL="73152" marR="73152" marT="27432" marB="27432">
+                    <a:solidFill>
+                      <a:srgbClr val="FFFFFF"/>
+                    </a:solidFill>
+                  </a:tcPr>
+                </a:tc>
+              </a:tr>
+              <a:tr h="713232">
+                <a:tc>
+                  <a:txBody>
+                    <a:bodyPr/>
+                    <a:lstStyle/>
+                    <a:p>
+                      <a:r>
+                        <a:rPr sz="1050" b="1">
+                          <a:solidFill>
+                            <a:srgbClr val="222A3F"/>
+                          </a:solidFill>
+                          <a:latin typeface="Cambria"/>
+                        </a:rPr>
+                        <a:t>Recovery</a:t>
+                      </a:r>
+                    </a:p>
+                  </a:txBody>
+                  <a:tcPr marL="73152" marR="73152" marT="27432" marB="27432">
+                    <a:solidFill>
+                      <a:srgbClr val="F2F5FA"/>
+                    </a:solidFill>
+                  </a:tcPr>
+                </a:tc>
+                <a:tc>
+                  <a:txBody>
+                    <a:bodyPr/>
+                    <a:lstStyle/>
+                    <a:p>
+                      <a:r>
+                        <a:rPr sz="1050" b="0">
+                          <a:solidFill>
+                            <a:srgbClr val="222A3F"/>
+                          </a:solidFill>
+                          <a:latin typeface="Cambria"/>
+                        </a:rPr>
+                        <a:t>Check both OLED LoRa screens: Group9 must read 912.875. Re-apply the channel URL, verify, power-cycle, verify again</a:t>
+                      </a:r>
+                    </a:p>
+                  </a:txBody>
+                  <a:tcPr marL="73152" marR="73152" marT="27432" marB="27432">
+                    <a:solidFill>
+                      <a:srgbClr val="F2F5FA"/>
+                    </a:solidFill>
+                  </a:tcPr>
+                </a:tc>
+              </a:tr>
+              <a:tr h="713232">
+                <a:tc>
+                  <a:txBody>
+                    <a:bodyPr/>
+                    <a:lstStyle/>
+                    <a:p>
+                      <a:r>
+                        <a:rPr sz="1050" b="1">
+                          <a:solidFill>
+                            <a:srgbClr val="222A3F"/>
+                          </a:solidFill>
+                          <a:latin typeface="Cambria"/>
+                        </a:rPr>
+                        <a:t>Rule it left</a:t>
+                      </a:r>
+                    </a:p>
+                  </a:txBody>
+                  <a:tcPr marL="73152" marR="73152" marT="27432" marB="27432">
+                    <a:solidFill>
+                      <a:srgbClr val="FFFFFF"/>
+                    </a:solidFill>
+                  </a:tcPr>
+                </a:tc>
+                <a:tc>
+                  <a:txBody>
+                    <a:bodyPr/>
+                    <a:lstStyle/>
+                    <a:p>
+                      <a:r>
+                        <a:rPr sz="1050" b="0">
+                          <a:solidFill>
+                            <a:srgbClr val="222A3F"/>
+                          </a:solidFill>
+                          <a:latin typeface="Cambria"/>
+                        </a:rPr>
+                        <a:t>Pre-flight: both OLEDs read 912.875 before any drive</a:t>
+                      </a:r>
+                    </a:p>
+                  </a:txBody>
+                  <a:tcPr marL="73152" marR="73152" marT="27432" marB="27432">
+                    <a:solidFill>
+                      <a:srgbClr val="FFFFFF"/>
+                    </a:solidFill>
+                  </a:tcPr>
+                </a:tc>
+              </a:tr>
+            </a:tbl>
+          </a:graphicData>
+        </a:graphic>
+      </p:graphicFrame>
+      <p:sp>
+        <p:nvSpPr>
+          <p:cNvPr id="16" name="TextBox 15"/>
+          <p:cNvSpPr txBox="1"/>
+          <p:nvPr/>
+        </p:nvSpPr>
+        <p:spPr>
+          <a:xfrm>
+            <a:off x="6126480" y="5257800"/>
+            <a:ext cx="5577840" cy="731520"/>
+          </a:xfrm>
+          <a:prstGeom prst="rect">
+            <a:avLst/>
+          </a:prstGeom>
+          <a:noFill/>
+        </p:spPr>
+        <p:txBody>
+          <a:bodyPr wrap="square" lIns="0" rIns="0" tIns="0" bIns="0">
+            <a:spAutoFit/>
+          </a:bodyPr>
+          <a:lstStyle/>
+          <a:p>
+            <a:pPr algn="l"/>
+            <a:r>
+              <a:rPr sz="1100" b="0" i="1">
+                <a:solidFill>
+                  <a:srgbClr val="5E6B85"/>
+                </a:solidFill>
+                <a:latin typeface="Cambria"/>
+              </a:rPr>
+              <a:t>Eleven entries in this form. Every one happened on this hardware and was reproduced or root-caused before being written down. The catalog is the part of the project a stranger could use tomorrow.</a:t>
+            </a:r>
+          </a:p>
+        </p:txBody>
+      </p:sp>
+    </p:spTree>
+  </p:cSld>
+  <p:clrMapOvr>
+    <a:masterClrMapping/>
+  </p:clrMapOvr>
+</p:sld>
+</file>
+
+<file path=ppt/slides/slide20.xml><?xml version="1.0" encoding="utf-8"?>
+<p:sld xmlns:a="http://schemas.openxmlformats.org/drawingml/2006/main" xmlns:p="http://schemas.openxmlformats.org/presentationml/2006/main" xmlns:r="http://schemas.openxmlformats.org/officeDocument/2006/relationships">
+  <p:cSld>
+    <p:spTree>
+      <p:nvGrpSpPr>
+        <p:cNvPr id="1" name=""/>
+        <p:cNvGrpSpPr/>
+        <p:nvPr/>
+      </p:nvGrpSpPr>
+      <p:grpSpPr/>
+      <p:sp>
+        <p:nvSpPr>
+          <p:cNvPr id="2" name="Rectangle 1"/>
+          <p:cNvSpPr/>
+          <p:nvPr/>
+        </p:nvSpPr>
+        <p:spPr>
+          <a:xfrm>
+            <a:off x="164592" y="146304"/>
+            <a:ext cx="11859768" cy="6565392"/>
+          </a:xfrm>
+          <a:prstGeom prst="rect">
+            <a:avLst/>
+          </a:prstGeom>
+          <a:noFill/>
+          <a:ln w="22225">
+            <a:solidFill>
+              <a:srgbClr val="16213D"/>
+            </a:solidFill>
+          </a:ln>
+          <a:effectLst/>
+        </p:spPr>
+        <p:style>
+          <a:lnRef idx="1">
+            <a:schemeClr val="accent1"/>
+          </a:lnRef>
+          <a:fillRef idx="3">
+            <a:schemeClr val="accent1"/>
+          </a:fillRef>
+          <a:effectRef idx="2">
+            <a:schemeClr val="accent1"/>
+          </a:effectRef>
+          <a:fontRef idx="minor">
+            <a:schemeClr val="lt1"/>
+          </a:fontRef>
+        </p:style>
+        <p:txBody>
+          <a:bodyPr rtlCol="0" anchor="ctr"/>
+          <a:lstStyle/>
+          <a:p>
+            <a:pPr algn="ctr"/>
+          </a:p>
+        </p:txBody>
+      </p:sp>
+      <p:sp>
+        <p:nvSpPr>
+          <p:cNvPr id="3" name="Rectangle 2"/>
+          <p:cNvSpPr/>
+          <p:nvPr/>
+        </p:nvSpPr>
+        <p:spPr>
+          <a:xfrm>
+            <a:off x="164592" y="6272784"/>
+            <a:ext cx="11859768" cy="12700"/>
+          </a:xfrm>
+          <a:prstGeom prst="rect">
+            <a:avLst/>
+          </a:prstGeom>
+          <a:solidFill>
+            <a:srgbClr val="16213D"/>
+          </a:solidFill>
+          <a:ln>
+            <a:noFill/>
+          </a:ln>
+          <a:effectLst/>
+        </p:spPr>
+        <p:style>
+          <a:lnRef idx="1">
+            <a:schemeClr val="accent1"/>
+          </a:lnRef>
+          <a:fillRef idx="3">
+            <a:schemeClr val="accent1"/>
+          </a:fillRef>
+          <a:effectRef idx="2">
+            <a:schemeClr val="accent1"/>
+          </a:effectRef>
+          <a:fontRef idx="minor">
+            <a:schemeClr val="lt1"/>
+          </a:fontRef>
+        </p:style>
+        <p:txBody>
+          <a:bodyPr rtlCol="0" anchor="ctr"/>
+          <a:lstStyle/>
+          <a:p>
+            <a:pPr algn="ctr"/>
+          </a:p>
+        </p:txBody>
+      </p:sp>
+      <p:sp>
+        <p:nvSpPr>
+          <p:cNvPr id="4" name="TextBox 3"/>
+          <p:cNvSpPr txBox="1"/>
+          <p:nvPr/>
+        </p:nvSpPr>
+        <p:spPr>
+          <a:xfrm>
+            <a:off x="320040" y="6345936"/>
+            <a:ext cx="4206240" cy="292608"/>
+          </a:xfrm>
+          <a:prstGeom prst="rect">
+            <a:avLst/>
+          </a:prstGeom>
+          <a:noFill/>
+        </p:spPr>
+        <p:txBody>
+          <a:bodyPr wrap="square" lIns="0" rIns="0" tIns="0" bIns="0">
+            <a:spAutoFit/>
+          </a:bodyPr>
+          <a:lstStyle/>
+          <a:p>
+            <a:pPr algn="l"/>
+            <a:r>
+              <a:rPr sz="900" b="0" i="0">
+                <a:solidFill>
+                  <a:srgbClr val="5E6B85"/>
+                </a:solidFill>
+                <a:latin typeface="Courier New"/>
+              </a:rPr>
+              <a:t>GROUP 9  |  OFF-GRID VEHICLE TRACKER</a:t>
+            </a:r>
+          </a:p>
+        </p:txBody>
+      </p:sp>
+      <p:sp>
+        <p:nvSpPr>
+          <p:cNvPr id="5" name="TextBox 4"/>
+          <p:cNvSpPr txBox="1"/>
+          <p:nvPr/>
+        </p:nvSpPr>
+        <p:spPr>
+          <a:xfrm>
+            <a:off x="4572000" y="6345936"/>
+            <a:ext cx="4206240" cy="292608"/>
+          </a:xfrm>
+          <a:prstGeom prst="rect">
+            <a:avLst/>
+          </a:prstGeom>
+          <a:noFill/>
+        </p:spPr>
+        <p:txBody>
+          <a:bodyPr wrap="square" lIns="0" rIns="0" tIns="0" bIns="0">
+            <a:spAutoFit/>
+          </a:bodyPr>
+          <a:lstStyle/>
+          <a:p>
+            <a:pPr algn="ctr"/>
+            <a:r>
+              <a:rPr sz="900" b="0" i="0">
+                <a:solidFill>
+                  <a:srgbClr val="5E6B85"/>
+                </a:solidFill>
+                <a:latin typeface="Courier New"/>
+              </a:rPr>
+              <a:t>PART II - ROOT CAUSE</a:t>
+            </a:r>
+          </a:p>
+        </p:txBody>
+      </p:sp>
+      <p:sp>
+        <p:nvSpPr>
+          <p:cNvPr id="6" name="TextBox 5"/>
+          <p:cNvSpPr txBox="1"/>
+          <p:nvPr/>
+        </p:nvSpPr>
+        <p:spPr>
+          <a:xfrm>
+            <a:off x="8869680" y="6345936"/>
+            <a:ext cx="3017520" cy="292608"/>
+          </a:xfrm>
+          <a:prstGeom prst="rect">
+            <a:avLst/>
+          </a:prstGeom>
+          <a:noFill/>
+        </p:spPr>
+        <p:txBody>
+          <a:bodyPr wrap="square" lIns="0" rIns="0" tIns="0" bIns="0">
+            <a:spAutoFit/>
+          </a:bodyPr>
+          <a:lstStyle/>
+          <a:p>
+            <a:pPr algn="r"/>
+            <a:r>
+              <a:rPr sz="900" b="0" i="0">
+                <a:solidFill>
+                  <a:srgbClr val="5E6B85"/>
+                </a:solidFill>
+                <a:latin typeface="Courier New"/>
+              </a:rPr>
+              <a:t>SHEET 20/21  REV D  2026-11-04</a:t>
             </a:r>
           </a:p>
         </p:txBody>
@@ -15982,7 +17523,7 @@
                 </a:solidFill>
                 <a:latin typeface="Cambria"/>
               </a:rPr>
-              <a:t>•  The investigation (sheets 13 to 17) was designed and run by the team with Claude (Anthropic) as an AI assistant: the AI drafted the experiment design, the flash-reading scripts and the analysis.</a:t>
+              <a:t>•  The investigation (sheets 13 to 18) was designed and run by the team with Claude (Anthropic) as an AI assistant: the AI drafted the experiment design, the flash-reading scripts and the analysis.</a:t>
             </a:r>
           </a:p>
           <a:p>
@@ -16027,7 +17568,7 @@
 </p:sld>
 </file>
 
-<file path=ppt/slides/slide2.xml><?xml version="1.0" encoding="utf-8"?>
+<file path=ppt/slides/slide21.xml><?xml version="1.0" encoding="utf-8"?>
 <p:sld xmlns:a="http://schemas.openxmlformats.org/drawingml/2006/main" xmlns:p="http://schemas.openxmlformats.org/presentationml/2006/main" xmlns:r="http://schemas.openxmlformats.org/officeDocument/2006/relationships">
   <p:cSld>
     <p:spTree>
@@ -16190,7 +17731,7 @@
                 </a:solidFill>
                 <a:latin typeface="Courier New"/>
               </a:rPr>
-              <a:t>PART I - THE FAILURES</a:t>
+              <a:t>CLOSE</a:t>
             </a:r>
           </a:p>
         </p:txBody>
@@ -16225,867 +17766,7 @@
                 </a:solidFill>
                 <a:latin typeface="Courier New"/>
               </a:rPr>
-              <a:t>SHEET 02/20  REV D  2026-11-04</a:t>
-            </a:r>
-          </a:p>
-        </p:txBody>
-      </p:sp>
-      <p:sp>
-        <p:nvSpPr>
-          <p:cNvPr id="7" name="TextBox 6"/>
-          <p:cNvSpPr txBox="1"/>
-          <p:nvPr/>
-        </p:nvSpPr>
-        <p:spPr>
-          <a:xfrm>
-            <a:off x="457200" y="329184"/>
-            <a:ext cx="9052560" cy="566928"/>
-          </a:xfrm>
-          <a:prstGeom prst="rect">
-            <a:avLst/>
-          </a:prstGeom>
-          <a:noFill/>
-        </p:spPr>
-        <p:txBody>
-          <a:bodyPr wrap="square" lIns="0" rIns="0" tIns="0" bIns="0">
-            <a:spAutoFit/>
-          </a:bodyPr>
-          <a:lstStyle/>
-          <a:p>
-            <a:pPr algn="l"/>
-            <a:r>
-              <a:rPr sz="2300" b="1" i="0" spc="200">
-                <a:solidFill>
-                  <a:srgbClr val="16213D"/>
-                </a:solidFill>
-                <a:latin typeface="Cambria"/>
-              </a:rPr>
-              <a:t>WHY THE FAILURES ARE THE DELIVERABLE</a:t>
-            </a:r>
-          </a:p>
-        </p:txBody>
-      </p:sp>
-      <p:sp>
-        <p:nvSpPr>
-          <p:cNvPr id="8" name="Rectangle 7"/>
-          <p:cNvSpPr/>
-          <p:nvPr/>
-        </p:nvSpPr>
-        <p:spPr>
-          <a:xfrm>
-            <a:off x="502920" y="1234440"/>
-            <a:ext cx="5394960" cy="1481328"/>
-          </a:xfrm>
-          <a:prstGeom prst="rect">
-            <a:avLst/>
-          </a:prstGeom>
-          <a:solidFill>
-            <a:srgbClr val="F2F5FA"/>
-          </a:solidFill>
-          <a:ln w="15875">
-            <a:solidFill>
-              <a:srgbClr val="16213D"/>
-            </a:solidFill>
-          </a:ln>
-          <a:effectLst/>
-        </p:spPr>
-        <p:style>
-          <a:lnRef idx="1">
-            <a:schemeClr val="accent1"/>
-          </a:lnRef>
-          <a:fillRef idx="3">
-            <a:schemeClr val="accent1"/>
-          </a:fillRef>
-          <a:effectRef idx="2">
-            <a:schemeClr val="accent1"/>
-          </a:effectRef>
-          <a:fontRef idx="minor">
-            <a:schemeClr val="lt1"/>
-          </a:fontRef>
-        </p:style>
-        <p:txBody>
-          <a:bodyPr rtlCol="0" anchor="ctr"/>
-          <a:lstStyle/>
-          <a:p>
-            <a:pPr algn="ctr"/>
-          </a:p>
-        </p:txBody>
-      </p:sp>
-      <p:sp>
-        <p:nvSpPr>
-          <p:cNvPr id="9" name="TextBox 8"/>
-          <p:cNvSpPr txBox="1"/>
-          <p:nvPr/>
-        </p:nvSpPr>
-        <p:spPr>
-          <a:xfrm>
-            <a:off x="667512" y="1353312"/>
-            <a:ext cx="5065776" cy="1243584"/>
-          </a:xfrm>
-          <a:prstGeom prst="rect">
-            <a:avLst/>
-          </a:prstGeom>
-          <a:noFill/>
-        </p:spPr>
-        <p:txBody>
-          <a:bodyPr wrap="square" lIns="0" rIns="0" tIns="0" bIns="0">
-            <a:spAutoFit/>
-          </a:bodyPr>
-          <a:lstStyle/>
-          <a:p>
-            <a:r>
-              <a:rPr sz="1300" b="1" spc="100">
-                <a:solidFill>
-                  <a:srgbClr val="16213D"/>
-                </a:solidFill>
-                <a:latin typeface="Cambria"/>
-              </a:rPr>
-              <a:t>A FAILURE IS ONLY USEFUL ONCE IT HAS A SIGNATURE</a:t>
-            </a:r>
-          </a:p>
-          <a:p>
-            <a:pPr>
-              <a:spcBef>
-                <a:spcPts val="400"/>
-              </a:spcBef>
-            </a:pPr>
-            <a:r>
-              <a:rPr sz="1200">
-                <a:solidFill>
-                  <a:srgbClr val="222A3F"/>
-                </a:solidFill>
-                <a:latin typeface="Cambria"/>
-              </a:rPr>
-              <a:t>Each catalog entry records the symptom exactly as it appears, the root cause, and the recovery, so the next person recognizes it in minutes, not days.</a:t>
-            </a:r>
-          </a:p>
-        </p:txBody>
-      </p:sp>
-      <p:sp>
-        <p:nvSpPr>
-          <p:cNvPr id="10" name="Rectangle 9"/>
-          <p:cNvSpPr/>
-          <p:nvPr/>
-        </p:nvSpPr>
-        <p:spPr>
-          <a:xfrm>
-            <a:off x="502920" y="2834640"/>
-            <a:ext cx="5394960" cy="1481328"/>
-          </a:xfrm>
-          <a:prstGeom prst="rect">
-            <a:avLst/>
-          </a:prstGeom>
-          <a:solidFill>
-            <a:srgbClr val="F2F5FA"/>
-          </a:solidFill>
-          <a:ln w="15875">
-            <a:solidFill>
-              <a:srgbClr val="16213D"/>
-            </a:solidFill>
-          </a:ln>
-          <a:effectLst/>
-        </p:spPr>
-        <p:style>
-          <a:lnRef idx="1">
-            <a:schemeClr val="accent1"/>
-          </a:lnRef>
-          <a:fillRef idx="3">
-            <a:schemeClr val="accent1"/>
-          </a:fillRef>
-          <a:effectRef idx="2">
-            <a:schemeClr val="accent1"/>
-          </a:effectRef>
-          <a:fontRef idx="minor">
-            <a:schemeClr val="lt1"/>
-          </a:fontRef>
-        </p:style>
-        <p:txBody>
-          <a:bodyPr rtlCol="0" anchor="ctr"/>
-          <a:lstStyle/>
-          <a:p>
-            <a:pPr algn="ctr"/>
-          </a:p>
-        </p:txBody>
-      </p:sp>
-      <p:sp>
-        <p:nvSpPr>
-          <p:cNvPr id="11" name="TextBox 10"/>
-          <p:cNvSpPr txBox="1"/>
-          <p:nvPr/>
-        </p:nvSpPr>
-        <p:spPr>
-          <a:xfrm>
-            <a:off x="667512" y="2953512"/>
-            <a:ext cx="5065776" cy="1243584"/>
-          </a:xfrm>
-          <a:prstGeom prst="rect">
-            <a:avLst/>
-          </a:prstGeom>
-          <a:noFill/>
-        </p:spPr>
-        <p:txBody>
-          <a:bodyPr wrap="square" lIns="0" rIns="0" tIns="0" bIns="0">
-            <a:spAutoFit/>
-          </a:bodyPr>
-          <a:lstStyle/>
-          <a:p>
-            <a:r>
-              <a:rPr sz="1300" b="1" spc="100">
-                <a:solidFill>
-                  <a:srgbClr val="16213D"/>
-                </a:solidFill>
-                <a:latin typeface="Cambria"/>
-              </a:rPr>
-              <a:t>EACH FAILURE PRODUCED A RULE OR A FEATURE</a:t>
-            </a:r>
-          </a:p>
-          <a:p>
-            <a:pPr>
-              <a:spcBef>
-                <a:spcPts val="400"/>
-              </a:spcBef>
-            </a:pPr>
-            <a:r>
-              <a:rPr sz="1200">
-                <a:solidFill>
-                  <a:srgbClr val="222A3F"/>
-                </a:solidFill>
-                <a:latin typeface="Cambria"/>
-              </a:rPr>
-              <a:t>Pre-flight checks, cadence-aware alarms, the course-up compass, the config snapshot, the LINK LOST alarm: none were in the plan. All came from something breaking.</a:t>
-            </a:r>
-          </a:p>
-        </p:txBody>
-      </p:sp>
-      <p:sp>
-        <p:nvSpPr>
-          <p:cNvPr id="12" name="Rectangle 11"/>
-          <p:cNvSpPr/>
-          <p:nvPr/>
-        </p:nvSpPr>
-        <p:spPr>
-          <a:xfrm>
-            <a:off x="502920" y="4434840"/>
-            <a:ext cx="5394960" cy="1481328"/>
-          </a:xfrm>
-          <a:prstGeom prst="rect">
-            <a:avLst/>
-          </a:prstGeom>
-          <a:solidFill>
-            <a:srgbClr val="F2F5FA"/>
-          </a:solidFill>
-          <a:ln w="15875">
-            <a:solidFill>
-              <a:srgbClr val="16213D"/>
-            </a:solidFill>
-          </a:ln>
-          <a:effectLst/>
-        </p:spPr>
-        <p:style>
-          <a:lnRef idx="1">
-            <a:schemeClr val="accent1"/>
-          </a:lnRef>
-          <a:fillRef idx="3">
-            <a:schemeClr val="accent1"/>
-          </a:fillRef>
-          <a:effectRef idx="2">
-            <a:schemeClr val="accent1"/>
-          </a:effectRef>
-          <a:fontRef idx="minor">
-            <a:schemeClr val="lt1"/>
-          </a:fontRef>
-        </p:style>
-        <p:txBody>
-          <a:bodyPr rtlCol="0" anchor="ctr"/>
-          <a:lstStyle/>
-          <a:p>
-            <a:pPr algn="ctr"/>
-          </a:p>
-        </p:txBody>
-      </p:sp>
-      <p:sp>
-        <p:nvSpPr>
-          <p:cNvPr id="13" name="TextBox 12"/>
-          <p:cNvSpPr txBox="1"/>
-          <p:nvPr/>
-        </p:nvSpPr>
-        <p:spPr>
-          <a:xfrm>
-            <a:off x="667512" y="4553712"/>
-            <a:ext cx="5065776" cy="1243584"/>
-          </a:xfrm>
-          <a:prstGeom prst="rect">
-            <a:avLst/>
-          </a:prstGeom>
-          <a:noFill/>
-        </p:spPr>
-        <p:txBody>
-          <a:bodyPr wrap="square" lIns="0" rIns="0" tIns="0" bIns="0">
-            <a:spAutoFit/>
-          </a:bodyPr>
-          <a:lstStyle/>
-          <a:p>
-            <a:r>
-              <a:rPr sz="1300" b="1" spc="100">
-                <a:solidFill>
-                  <a:srgbClr val="16213D"/>
-                </a:solidFill>
-                <a:latin typeface="Cambria"/>
-              </a:rPr>
-              <a:t>FIELD EQUIPMENT FAILS BETWEEN OUTINGS</a:t>
-            </a:r>
-          </a:p>
-          <a:p>
-            <a:pPr>
-              <a:spcBef>
-                <a:spcPts val="400"/>
-              </a:spcBef>
-            </a:pPr>
-            <a:r>
-              <a:rPr sz="1200">
-                <a:solidFill>
-                  <a:srgbClr val="222A3F"/>
-                </a:solidFill>
-                <a:latin typeface="Cambria"/>
-              </a:rPr>
-              <a:t>Three of ten failures struck the night before a test. Every one was cleared in time because its signature had already been written down.</a:t>
-            </a:r>
-          </a:p>
-        </p:txBody>
-      </p:sp>
-      <p:sp>
-        <p:nvSpPr>
-          <p:cNvPr id="14" name="TextBox 13"/>
-          <p:cNvSpPr txBox="1"/>
-          <p:nvPr/>
-        </p:nvSpPr>
-        <p:spPr>
-          <a:xfrm>
-            <a:off x="6126480" y="1234440"/>
-            <a:ext cx="5577840" cy="274320"/>
-          </a:xfrm>
-          <a:prstGeom prst="rect">
-            <a:avLst/>
-          </a:prstGeom>
-          <a:noFill/>
-        </p:spPr>
-        <p:txBody>
-          <a:bodyPr wrap="square" lIns="0" rIns="0" tIns="0" bIns="0">
-            <a:spAutoFit/>
-          </a:bodyPr>
-          <a:lstStyle/>
-          <a:p>
-            <a:pPr algn="l"/>
-            <a:r>
-              <a:rPr sz="1100" b="1" i="0">
-                <a:solidFill>
-                  <a:srgbClr val="E58E1A"/>
-                </a:solidFill>
-                <a:latin typeface="Courier New"/>
-              </a:rPr>
-              <a:t>WHAT ONE CATALOG ENTRY LOOKS LIKE</a:t>
-            </a:r>
-          </a:p>
-        </p:txBody>
-      </p:sp>
-      <p:graphicFrame>
-        <p:nvGraphicFramePr>
-          <p:cNvPr id="15" name="Table 14"/>
-          <p:cNvGraphicFramePr>
-            <a:graphicFrameLocks noGrp="1"/>
-          </p:cNvGraphicFramePr>
-          <p:nvPr/>
-        </p:nvGraphicFramePr>
-        <p:xfrm>
-          <a:off x="6126480" y="1554480"/>
-          <a:ext cx="5577840" cy="3566160"/>
-        </p:xfrm>
-        <a:graphic>
-          <a:graphicData uri="http://schemas.openxmlformats.org/drawingml/2006/table">
-            <a:tbl>
-              <a:tblPr firstRow="1" bandRow="1">
-                <a:tableStyleId>{5C22544A-7EE6-4342-B048-85BDC9FD1C3A}</a:tableStyleId>
-              </a:tblPr>
-              <a:tblGrid>
-                <a:gridCol w="1143000"/>
-                <a:gridCol w="4434840"/>
-              </a:tblGrid>
-              <a:tr h="713232">
-                <a:tc>
-                  <a:txBody>
-                    <a:bodyPr/>
-                    <a:lstStyle/>
-                    <a:p>
-                      <a:r>
-                        <a:rPr sz="1050" b="1">
-                          <a:solidFill>
-                            <a:srgbClr val="FFFFFF"/>
-                          </a:solidFill>
-                          <a:latin typeface="Cambria"/>
-                        </a:rPr>
-                        <a:t>Field</a:t>
-                      </a:r>
-                    </a:p>
-                  </a:txBody>
-                  <a:tcPr marL="73152" marR="73152" marT="27432" marB="27432">
-                    <a:solidFill>
-                      <a:srgbClr val="16213D"/>
-                    </a:solidFill>
-                  </a:tcPr>
-                </a:tc>
-                <a:tc>
-                  <a:txBody>
-                    <a:bodyPr/>
-                    <a:lstStyle/>
-                    <a:p>
-                      <a:r>
-                        <a:rPr sz="1050" b="1">
-                          <a:solidFill>
-                            <a:srgbClr val="FFFFFF"/>
-                          </a:solidFill>
-                          <a:latin typeface="Cambria"/>
-                        </a:rPr>
-                        <a:t>Entry 1, Technical Manual Section 16</a:t>
-                      </a:r>
-                    </a:p>
-                  </a:txBody>
-                  <a:tcPr marL="73152" marR="73152" marT="27432" marB="27432">
-                    <a:solidFill>
-                      <a:srgbClr val="16213D"/>
-                    </a:solidFill>
-                  </a:tcPr>
-                </a:tc>
-              </a:tr>
-              <a:tr h="713232">
-                <a:tc>
-                  <a:txBody>
-                    <a:bodyPr/>
-                    <a:lstStyle/>
-                    <a:p>
-                      <a:r>
-                        <a:rPr sz="1050" b="1">
-                          <a:solidFill>
-                            <a:srgbClr val="222A3F"/>
-                          </a:solidFill>
-                          <a:latin typeface="Cambria"/>
-                        </a:rPr>
-                        <a:t>Symptom</a:t>
-                      </a:r>
-                    </a:p>
-                  </a:txBody>
-                  <a:tcPr marL="73152" marR="73152" marT="27432" marB="27432">
-                    <a:solidFill>
-                      <a:srgbClr val="F2F5FA"/>
-                    </a:solidFill>
-                  </a:tcPr>
-                </a:tc>
-                <a:tc>
-                  <a:txBody>
-                    <a:bodyPr/>
-                    <a:lstStyle/>
-                    <a:p>
-                      <a:r>
-                        <a:rPr sz="1050" b="0">
-                          <a:solidFill>
-                            <a:srgbClr val="222A3F"/>
-                          </a:solidFill>
-                          <a:latin typeface="Cambria"/>
-                        </a:rPr>
-                        <a:t>Total mutual silence; configs read back identical; 0 percent channel utilization</a:t>
-                      </a:r>
-                    </a:p>
-                  </a:txBody>
-                  <a:tcPr marL="73152" marR="73152" marT="27432" marB="27432">
-                    <a:solidFill>
-                      <a:srgbClr val="F2F5FA"/>
-                    </a:solidFill>
-                  </a:tcPr>
-                </a:tc>
-              </a:tr>
-              <a:tr h="713232">
-                <a:tc>
-                  <a:txBody>
-                    <a:bodyPr/>
-                    <a:lstStyle/>
-                    <a:p>
-                      <a:r>
-                        <a:rPr sz="1050" b="1">
-                          <a:solidFill>
-                            <a:srgbClr val="222A3F"/>
-                          </a:solidFill>
-                          <a:latin typeface="Cambria"/>
-                        </a:rPr>
-                        <a:t>Root cause</a:t>
-                      </a:r>
-                    </a:p>
-                  </a:txBody>
-                  <a:tcPr marL="73152" marR="73152" marT="27432" marB="27432">
-                    <a:solidFill>
-                      <a:srgbClr val="FFFFFF"/>
-                    </a:solidFill>
-                  </a:tcPr>
-                </a:tc>
-                <a:tc>
-                  <a:txBody>
-                    <a:bodyPr/>
-                    <a:lstStyle/>
-                    <a:p>
-                      <a:r>
-                        <a:rPr sz="1050" b="0">
-                          <a:solidFill>
-                            <a:srgbClr val="222A3F"/>
-                          </a:solidFill>
-                          <a:latin typeface="Cambria"/>
-                        </a:rPr>
-                        <a:t>Frequency-slot mismatch: a channel write silently reverted, leaving the radios on different slots with the same key</a:t>
-                      </a:r>
-                    </a:p>
-                  </a:txBody>
-                  <a:tcPr marL="73152" marR="73152" marT="27432" marB="27432">
-                    <a:solidFill>
-                      <a:srgbClr val="FFFFFF"/>
-                    </a:solidFill>
-                  </a:tcPr>
-                </a:tc>
-              </a:tr>
-              <a:tr h="713232">
-                <a:tc>
-                  <a:txBody>
-                    <a:bodyPr/>
-                    <a:lstStyle/>
-                    <a:p>
-                      <a:r>
-                        <a:rPr sz="1050" b="1">
-                          <a:solidFill>
-                            <a:srgbClr val="222A3F"/>
-                          </a:solidFill>
-                          <a:latin typeface="Cambria"/>
-                        </a:rPr>
-                        <a:t>Recovery</a:t>
-                      </a:r>
-                    </a:p>
-                  </a:txBody>
-                  <a:tcPr marL="73152" marR="73152" marT="27432" marB="27432">
-                    <a:solidFill>
-                      <a:srgbClr val="F2F5FA"/>
-                    </a:solidFill>
-                  </a:tcPr>
-                </a:tc>
-                <a:tc>
-                  <a:txBody>
-                    <a:bodyPr/>
-                    <a:lstStyle/>
-                    <a:p>
-                      <a:r>
-                        <a:rPr sz="1050" b="0">
-                          <a:solidFill>
-                            <a:srgbClr val="222A3F"/>
-                          </a:solidFill>
-                          <a:latin typeface="Cambria"/>
-                        </a:rPr>
-                        <a:t>Check both OLED LoRa screens: Group9 must read 912.875. Re-apply the channel URL, verify, power-cycle, verify again</a:t>
-                      </a:r>
-                    </a:p>
-                  </a:txBody>
-                  <a:tcPr marL="73152" marR="73152" marT="27432" marB="27432">
-                    <a:solidFill>
-                      <a:srgbClr val="F2F5FA"/>
-                    </a:solidFill>
-                  </a:tcPr>
-                </a:tc>
-              </a:tr>
-              <a:tr h="713232">
-                <a:tc>
-                  <a:txBody>
-                    <a:bodyPr/>
-                    <a:lstStyle/>
-                    <a:p>
-                      <a:r>
-                        <a:rPr sz="1050" b="1">
-                          <a:solidFill>
-                            <a:srgbClr val="222A3F"/>
-                          </a:solidFill>
-                          <a:latin typeface="Cambria"/>
-                        </a:rPr>
-                        <a:t>Rule it left</a:t>
-                      </a:r>
-                    </a:p>
-                  </a:txBody>
-                  <a:tcPr marL="73152" marR="73152" marT="27432" marB="27432">
-                    <a:solidFill>
-                      <a:srgbClr val="FFFFFF"/>
-                    </a:solidFill>
-                  </a:tcPr>
-                </a:tc>
-                <a:tc>
-                  <a:txBody>
-                    <a:bodyPr/>
-                    <a:lstStyle/>
-                    <a:p>
-                      <a:r>
-                        <a:rPr sz="1050" b="0">
-                          <a:solidFill>
-                            <a:srgbClr val="222A3F"/>
-                          </a:solidFill>
-                          <a:latin typeface="Cambria"/>
-                        </a:rPr>
-                        <a:t>Pre-flight: both OLEDs read 912.875 before any drive</a:t>
-                      </a:r>
-                    </a:p>
-                  </a:txBody>
-                  <a:tcPr marL="73152" marR="73152" marT="27432" marB="27432">
-                    <a:solidFill>
-                      <a:srgbClr val="FFFFFF"/>
-                    </a:solidFill>
-                  </a:tcPr>
-                </a:tc>
-              </a:tr>
-            </a:tbl>
-          </a:graphicData>
-        </a:graphic>
-      </p:graphicFrame>
-      <p:sp>
-        <p:nvSpPr>
-          <p:cNvPr id="16" name="TextBox 15"/>
-          <p:cNvSpPr txBox="1"/>
-          <p:nvPr/>
-        </p:nvSpPr>
-        <p:spPr>
-          <a:xfrm>
-            <a:off x="6126480" y="5257800"/>
-            <a:ext cx="5577840" cy="731520"/>
-          </a:xfrm>
-          <a:prstGeom prst="rect">
-            <a:avLst/>
-          </a:prstGeom>
-          <a:noFill/>
-        </p:spPr>
-        <p:txBody>
-          <a:bodyPr wrap="square" lIns="0" rIns="0" tIns="0" bIns="0">
-            <a:spAutoFit/>
-          </a:bodyPr>
-          <a:lstStyle/>
-          <a:p>
-            <a:pPr algn="l"/>
-            <a:r>
-              <a:rPr sz="1100" b="0" i="1">
-                <a:solidFill>
-                  <a:srgbClr val="5E6B85"/>
-                </a:solidFill>
-                <a:latin typeface="Cambria"/>
-              </a:rPr>
-              <a:t>Eleven entries in this form. Every one happened on this hardware and was reproduced or root-caused before being written down. The catalog is the part of the project a stranger could use tomorrow.</a:t>
-            </a:r>
-          </a:p>
-        </p:txBody>
-      </p:sp>
-    </p:spTree>
-  </p:cSld>
-  <p:clrMapOvr>
-    <a:masterClrMapping/>
-  </p:clrMapOvr>
-</p:sld>
-</file>
-
-<file path=ppt/slides/slide20.xml><?xml version="1.0" encoding="utf-8"?>
-<p:sld xmlns:a="http://schemas.openxmlformats.org/drawingml/2006/main" xmlns:p="http://schemas.openxmlformats.org/presentationml/2006/main" xmlns:r="http://schemas.openxmlformats.org/officeDocument/2006/relationships">
-  <p:cSld>
-    <p:spTree>
-      <p:nvGrpSpPr>
-        <p:cNvPr id="1" name=""/>
-        <p:cNvGrpSpPr/>
-        <p:nvPr/>
-      </p:nvGrpSpPr>
-      <p:grpSpPr/>
-      <p:sp>
-        <p:nvSpPr>
-          <p:cNvPr id="2" name="Rectangle 1"/>
-          <p:cNvSpPr/>
-          <p:nvPr/>
-        </p:nvSpPr>
-        <p:spPr>
-          <a:xfrm>
-            <a:off x="164592" y="146304"/>
-            <a:ext cx="11859768" cy="6565392"/>
-          </a:xfrm>
-          <a:prstGeom prst="rect">
-            <a:avLst/>
-          </a:prstGeom>
-          <a:noFill/>
-          <a:ln w="22225">
-            <a:solidFill>
-              <a:srgbClr val="16213D"/>
-            </a:solidFill>
-          </a:ln>
-          <a:effectLst/>
-        </p:spPr>
-        <p:style>
-          <a:lnRef idx="1">
-            <a:schemeClr val="accent1"/>
-          </a:lnRef>
-          <a:fillRef idx="3">
-            <a:schemeClr val="accent1"/>
-          </a:fillRef>
-          <a:effectRef idx="2">
-            <a:schemeClr val="accent1"/>
-          </a:effectRef>
-          <a:fontRef idx="minor">
-            <a:schemeClr val="lt1"/>
-          </a:fontRef>
-        </p:style>
-        <p:txBody>
-          <a:bodyPr rtlCol="0" anchor="ctr"/>
-          <a:lstStyle/>
-          <a:p>
-            <a:pPr algn="ctr"/>
-          </a:p>
-        </p:txBody>
-      </p:sp>
-      <p:sp>
-        <p:nvSpPr>
-          <p:cNvPr id="3" name="Rectangle 2"/>
-          <p:cNvSpPr/>
-          <p:nvPr/>
-        </p:nvSpPr>
-        <p:spPr>
-          <a:xfrm>
-            <a:off x="164592" y="6272784"/>
-            <a:ext cx="11859768" cy="12700"/>
-          </a:xfrm>
-          <a:prstGeom prst="rect">
-            <a:avLst/>
-          </a:prstGeom>
-          <a:solidFill>
-            <a:srgbClr val="16213D"/>
-          </a:solidFill>
-          <a:ln>
-            <a:noFill/>
-          </a:ln>
-          <a:effectLst/>
-        </p:spPr>
-        <p:style>
-          <a:lnRef idx="1">
-            <a:schemeClr val="accent1"/>
-          </a:lnRef>
-          <a:fillRef idx="3">
-            <a:schemeClr val="accent1"/>
-          </a:fillRef>
-          <a:effectRef idx="2">
-            <a:schemeClr val="accent1"/>
-          </a:effectRef>
-          <a:fontRef idx="minor">
-            <a:schemeClr val="lt1"/>
-          </a:fontRef>
-        </p:style>
-        <p:txBody>
-          <a:bodyPr rtlCol="0" anchor="ctr"/>
-          <a:lstStyle/>
-          <a:p>
-            <a:pPr algn="ctr"/>
-          </a:p>
-        </p:txBody>
-      </p:sp>
-      <p:sp>
-        <p:nvSpPr>
-          <p:cNvPr id="4" name="TextBox 3"/>
-          <p:cNvSpPr txBox="1"/>
-          <p:nvPr/>
-        </p:nvSpPr>
-        <p:spPr>
-          <a:xfrm>
-            <a:off x="320040" y="6345936"/>
-            <a:ext cx="4206240" cy="292608"/>
-          </a:xfrm>
-          <a:prstGeom prst="rect">
-            <a:avLst/>
-          </a:prstGeom>
-          <a:noFill/>
-        </p:spPr>
-        <p:txBody>
-          <a:bodyPr wrap="square" lIns="0" rIns="0" tIns="0" bIns="0">
-            <a:spAutoFit/>
-          </a:bodyPr>
-          <a:lstStyle/>
-          <a:p>
-            <a:pPr algn="l"/>
-            <a:r>
-              <a:rPr sz="900" b="0" i="0">
-                <a:solidFill>
-                  <a:srgbClr val="5E6B85"/>
-                </a:solidFill>
-                <a:latin typeface="Courier New"/>
-              </a:rPr>
-              <a:t>GROUP 9  |  OFF-GRID VEHICLE TRACKER</a:t>
-            </a:r>
-          </a:p>
-        </p:txBody>
-      </p:sp>
-      <p:sp>
-        <p:nvSpPr>
-          <p:cNvPr id="5" name="TextBox 4"/>
-          <p:cNvSpPr txBox="1"/>
-          <p:nvPr/>
-        </p:nvSpPr>
-        <p:spPr>
-          <a:xfrm>
-            <a:off x="4572000" y="6345936"/>
-            <a:ext cx="4206240" cy="292608"/>
-          </a:xfrm>
-          <a:prstGeom prst="rect">
-            <a:avLst/>
-          </a:prstGeom>
-          <a:noFill/>
-        </p:spPr>
-        <p:txBody>
-          <a:bodyPr wrap="square" lIns="0" rIns="0" tIns="0" bIns="0">
-            <a:spAutoFit/>
-          </a:bodyPr>
-          <a:lstStyle/>
-          <a:p>
-            <a:pPr algn="ctr"/>
-            <a:r>
-              <a:rPr sz="900" b="0" i="0">
-                <a:solidFill>
-                  <a:srgbClr val="5E6B85"/>
-                </a:solidFill>
-                <a:latin typeface="Courier New"/>
-              </a:rPr>
-              <a:t>CLOSE</a:t>
-            </a:r>
-          </a:p>
-        </p:txBody>
-      </p:sp>
-      <p:sp>
-        <p:nvSpPr>
-          <p:cNvPr id="6" name="TextBox 5"/>
-          <p:cNvSpPr txBox="1"/>
-          <p:nvPr/>
-        </p:nvSpPr>
-        <p:spPr>
-          <a:xfrm>
-            <a:off x="8869680" y="6345936"/>
-            <a:ext cx="3017520" cy="292608"/>
-          </a:xfrm>
-          <a:prstGeom prst="rect">
-            <a:avLst/>
-          </a:prstGeom>
-          <a:noFill/>
-        </p:spPr>
-        <p:txBody>
-          <a:bodyPr wrap="square" lIns="0" rIns="0" tIns="0" bIns="0">
-            <a:spAutoFit/>
-          </a:bodyPr>
-          <a:lstStyle/>
-          <a:p>
-            <a:pPr algn="r"/>
-            <a:r>
-              <a:rPr sz="900" b="0" i="0">
-                <a:solidFill>
-                  <a:srgbClr val="5E6B85"/>
-                </a:solidFill>
-                <a:latin typeface="Courier New"/>
-              </a:rPr>
-              <a:t>SHEET 20/20  REV D  2026-11-04</a:t>
+              <a:t>SHEET 21/21  REV D  2026-11-04</a:t>
             </a:r>
           </a:p>
         </p:txBody>
@@ -18202,7 +18883,7 @@
                 </a:solidFill>
                 <a:latin typeface="Courier New"/>
               </a:rPr>
-              <a:t>SHEET 03/20  REV D  2026-11-04</a:t>
+              <a:t>SHEET 03/21  REV D  2026-11-04</a:t>
             </a:r>
           </a:p>
         </p:txBody>
@@ -18507,7 +19188,7 @@
                 </a:solidFill>
                 <a:latin typeface="Courier New"/>
               </a:rPr>
-              <a:t>SHEET 04/20  REV D  2026-11-04</a:t>
+              <a:t>SHEET 04/21  REV D  2026-11-04</a:t>
             </a:r>
           </a:p>
         </p:txBody>
@@ -19466,7 +20147,7 @@
                 </a:solidFill>
                 <a:latin typeface="Courier New"/>
               </a:rPr>
-              <a:t>SHEET 05/20  REV D  2026-11-04</a:t>
+              <a:t>SHEET 05/21  REV D  2026-11-04</a:t>
             </a:r>
           </a:p>
         </p:txBody>
@@ -20425,7 +21106,7 @@
                 </a:solidFill>
                 <a:latin typeface="Courier New"/>
               </a:rPr>
-              <a:t>SHEET 06/20  REV D  2026-11-04</a:t>
+              <a:t>SHEET 06/21  REV D  2026-11-04</a:t>
             </a:r>
           </a:p>
         </p:txBody>
@@ -21384,7 +22065,7 @@
                 </a:solidFill>
                 <a:latin typeface="Courier New"/>
               </a:rPr>
-              <a:t>SHEET 07/20  REV D  2026-11-04</a:t>
+              <a:t>SHEET 07/21  REV D  2026-11-04</a:t>
             </a:r>
           </a:p>
         </p:txBody>
@@ -22145,7 +22826,7 @@
                 </a:solidFill>
                 <a:latin typeface="Courier New"/>
               </a:rPr>
-              <a:t>SHEET 08/20  REV D  2026-11-04</a:t>
+              <a:t>SHEET 08/21  REV D  2026-11-04</a:t>
             </a:r>
           </a:p>
         </p:txBody>
@@ -24555,7 +25236,7 @@
                 </a:solidFill>
                 <a:latin typeface="Courier New"/>
               </a:rPr>
-              <a:t>SHEET 09/20  REV D  2026-11-04</a:t>
+              <a:t>SHEET 09/21  REV D  2026-11-04</a:t>
             </a:r>
           </a:p>
         </p:txBody>

</xml_diff>

<commit_message>
Full deck: presenter names on every sheet; the technical sheets on Deo
Co-Authored-By: Claude Fable 5.1 <noreply@anthropic.com>
</commit_message>
<xml_diff>
--- a/docs/presentations/Group9_Presentation.pptx
+++ b/docs/presentations/Group9_Presentation.pptx
@@ -8202,14 +8202,60 @@
       </p:sp>
       <p:sp>
         <p:nvSpPr>
-          <p:cNvPr id="7" name="TextBox 6"/>
+          <p:cNvPr id="7" name="Rectangle 6"/>
+          <p:cNvSpPr/>
+          <p:nvPr/>
+        </p:nvSpPr>
+        <p:spPr>
+          <a:xfrm>
+            <a:off x="9646920" y="347472"/>
+            <a:ext cx="2148840" cy="420624"/>
+          </a:xfrm>
+          <a:prstGeom prst="rect">
+            <a:avLst/>
+          </a:prstGeom>
+          <a:solidFill>
+            <a:srgbClr val="FFFFFF"/>
+          </a:solidFill>
+          <a:ln w="19050">
+            <a:solidFill>
+              <a:srgbClr val="D9488C"/>
+            </a:solidFill>
+          </a:ln>
+          <a:effectLst/>
+        </p:spPr>
+        <p:style>
+          <a:lnRef idx="1">
+            <a:schemeClr val="accent1"/>
+          </a:lnRef>
+          <a:fillRef idx="3">
+            <a:schemeClr val="accent1"/>
+          </a:fillRef>
+          <a:effectRef idx="2">
+            <a:schemeClr val="accent1"/>
+          </a:effectRef>
+          <a:fontRef idx="minor">
+            <a:schemeClr val="lt1"/>
+          </a:fontRef>
+        </p:style>
+        <p:txBody>
+          <a:bodyPr rtlCol="0" anchor="ctr"/>
+          <a:lstStyle/>
+          <a:p>
+            <a:pPr algn="ctr"/>
+          </a:p>
+        </p:txBody>
+      </p:sp>
+      <p:sp>
+        <p:nvSpPr>
+          <p:cNvPr id="8" name="TextBox 7"/>
           <p:cNvSpPr txBox="1"/>
           <p:nvPr/>
         </p:nvSpPr>
         <p:spPr>
           <a:xfrm>
-            <a:off x="457200" y="329184"/>
-            <a:ext cx="9052560" cy="566928"/>
+            <a:off x="9646920" y="402336"/>
+            <a:ext cx="2148840" cy="310896"/>
           </a:xfrm>
           <a:prstGeom prst="rect">
             <a:avLst/>
@@ -8222,6 +8268,41 @@
           </a:bodyPr>
           <a:lstStyle/>
           <a:p>
+            <a:pPr algn="ctr"/>
+            <a:r>
+              <a:rPr sz="1100" b="1" i="0">
+                <a:solidFill>
+                  <a:srgbClr val="D9488C"/>
+                </a:solidFill>
+                <a:latin typeface="Courier New"/>
+              </a:rPr>
+              <a:t>OWNER: CANNON</a:t>
+            </a:r>
+          </a:p>
+        </p:txBody>
+      </p:sp>
+      <p:sp>
+        <p:nvSpPr>
+          <p:cNvPr id="9" name="TextBox 8"/>
+          <p:cNvSpPr txBox="1"/>
+          <p:nvPr/>
+        </p:nvSpPr>
+        <p:spPr>
+          <a:xfrm>
+            <a:off x="457200" y="329184"/>
+            <a:ext cx="9052560" cy="566928"/>
+          </a:xfrm>
+          <a:prstGeom prst="rect">
+            <a:avLst/>
+          </a:prstGeom>
+          <a:noFill/>
+        </p:spPr>
+        <p:txBody>
+          <a:bodyPr wrap="square" lIns="0" rIns="0" tIns="0" bIns="0">
+            <a:spAutoFit/>
+          </a:bodyPr>
+          <a:lstStyle/>
+          <a:p>
             <a:pPr algn="l"/>
             <a:r>
               <a:rPr sz="2300" b="1" i="0" spc="200">
@@ -8237,7 +8318,7 @@
       </p:sp>
       <p:sp>
         <p:nvSpPr>
-          <p:cNvPr id="8" name="TextBox 7"/>
+          <p:cNvPr id="10" name="TextBox 9"/>
           <p:cNvSpPr txBox="1"/>
           <p:nvPr/>
         </p:nvSpPr>
@@ -8272,7 +8353,7 @@
       </p:sp>
       <p:graphicFrame>
         <p:nvGraphicFramePr>
-          <p:cNvPr id="9" name="Table 8"/>
+          <p:cNvPr id="11" name="Table 10"/>
           <p:cNvGraphicFramePr>
             <a:graphicFrameLocks noGrp="1"/>
           </p:cNvGraphicFramePr>
@@ -8840,7 +8921,7 @@
       </p:graphicFrame>
       <p:sp>
         <p:nvSpPr>
-          <p:cNvPr id="10" name="Rectangle 9"/>
+          <p:cNvPr id="12" name="Rectangle 11"/>
           <p:cNvSpPr/>
           <p:nvPr/>
         </p:nvSpPr>
@@ -8884,7 +8965,7 @@
       </p:sp>
       <p:sp>
         <p:nvSpPr>
-          <p:cNvPr id="11" name="TextBox 10"/>
+          <p:cNvPr id="13" name="TextBox 12"/>
           <p:cNvSpPr txBox="1"/>
           <p:nvPr/>
         </p:nvSpPr>
@@ -8919,7 +9000,7 @@
       </p:sp>
       <p:sp>
         <p:nvSpPr>
-          <p:cNvPr id="12" name="TextBox 11"/>
+          <p:cNvPr id="14" name="TextBox 13"/>
           <p:cNvSpPr txBox="1"/>
           <p:nvPr/>
         </p:nvSpPr>
@@ -8964,7 +9045,7 @@
       </p:sp>
       <p:sp>
         <p:nvSpPr>
-          <p:cNvPr id="13" name="TextBox 12"/>
+          <p:cNvPr id="15" name="TextBox 14"/>
           <p:cNvSpPr txBox="1"/>
           <p:nvPr/>
         </p:nvSpPr>
@@ -11190,14 +11271,60 @@
       </p:sp>
       <p:sp>
         <p:nvSpPr>
-          <p:cNvPr id="7" name="TextBox 6"/>
+          <p:cNvPr id="7" name="Rectangle 6"/>
+          <p:cNvSpPr/>
+          <p:nvPr/>
+        </p:nvSpPr>
+        <p:spPr>
+          <a:xfrm>
+            <a:off x="9646920" y="347472"/>
+            <a:ext cx="2148840" cy="420624"/>
+          </a:xfrm>
+          <a:prstGeom prst="rect">
+            <a:avLst/>
+          </a:prstGeom>
+          <a:solidFill>
+            <a:srgbClr val="FFFFFF"/>
+          </a:solidFill>
+          <a:ln w="19050">
+            <a:solidFill>
+              <a:srgbClr val="1199BD"/>
+            </a:solidFill>
+          </a:ln>
+          <a:effectLst/>
+        </p:spPr>
+        <p:style>
+          <a:lnRef idx="1">
+            <a:schemeClr val="accent1"/>
+          </a:lnRef>
+          <a:fillRef idx="3">
+            <a:schemeClr val="accent1"/>
+          </a:fillRef>
+          <a:effectRef idx="2">
+            <a:schemeClr val="accent1"/>
+          </a:effectRef>
+          <a:fontRef idx="minor">
+            <a:schemeClr val="lt1"/>
+          </a:fontRef>
+        </p:style>
+        <p:txBody>
+          <a:bodyPr rtlCol="0" anchor="ctr"/>
+          <a:lstStyle/>
+          <a:p>
+            <a:pPr algn="ctr"/>
+          </a:p>
+        </p:txBody>
+      </p:sp>
+      <p:sp>
+        <p:nvSpPr>
+          <p:cNvPr id="8" name="TextBox 7"/>
           <p:cNvSpPr txBox="1"/>
           <p:nvPr/>
         </p:nvSpPr>
         <p:spPr>
           <a:xfrm>
-            <a:off x="457200" y="329184"/>
-            <a:ext cx="9052560" cy="566928"/>
+            <a:off x="9646920" y="402336"/>
+            <a:ext cx="2148840" cy="310896"/>
           </a:xfrm>
           <a:prstGeom prst="rect">
             <a:avLst/>
@@ -11210,6 +11337,41 @@
           </a:bodyPr>
           <a:lstStyle/>
           <a:p>
+            <a:pPr algn="ctr"/>
+            <a:r>
+              <a:rPr sz="1100" b="1" i="0">
+                <a:solidFill>
+                  <a:srgbClr val="1199BD"/>
+                </a:solidFill>
+                <a:latin typeface="Courier New"/>
+              </a:rPr>
+              <a:t>OWNER: DEO</a:t>
+            </a:r>
+          </a:p>
+        </p:txBody>
+      </p:sp>
+      <p:sp>
+        <p:nvSpPr>
+          <p:cNvPr id="9" name="TextBox 8"/>
+          <p:cNvSpPr txBox="1"/>
+          <p:nvPr/>
+        </p:nvSpPr>
+        <p:spPr>
+          <a:xfrm>
+            <a:off x="457200" y="329184"/>
+            <a:ext cx="9052560" cy="566928"/>
+          </a:xfrm>
+          <a:prstGeom prst="rect">
+            <a:avLst/>
+          </a:prstGeom>
+          <a:noFill/>
+        </p:spPr>
+        <p:txBody>
+          <a:bodyPr wrap="square" lIns="0" rIns="0" tIns="0" bIns="0">
+            <a:spAutoFit/>
+          </a:bodyPr>
+          <a:lstStyle/>
+          <a:p>
             <a:pPr algn="l"/>
             <a:r>
               <a:rPr sz="2300" b="1" i="0" spc="200">
@@ -11225,7 +11387,7 @@
       </p:sp>
       <p:sp>
         <p:nvSpPr>
-          <p:cNvPr id="8" name="TextBox 7"/>
+          <p:cNvPr id="10" name="TextBox 9"/>
           <p:cNvSpPr txBox="1"/>
           <p:nvPr/>
         </p:nvSpPr>
@@ -11260,7 +11422,7 @@
       </p:sp>
       <p:pic>
         <p:nvPicPr>
-          <p:cNvPr id="9" name="Picture 8" descr="g_maps_compare.png"/>
+          <p:cNvPr id="11" name="Picture 10" descr="g_maps_compare.png"/>
           <p:cNvPicPr>
             <a:picLocks noChangeAspect="1"/>
           </p:cNvPicPr>
@@ -11284,7 +11446,7 @@
       </p:pic>
       <p:sp>
         <p:nvSpPr>
-          <p:cNvPr id="10" name="TextBox 9"/>
+          <p:cNvPr id="12" name="TextBox 11"/>
           <p:cNvSpPr txBox="1"/>
           <p:nvPr/>
         </p:nvSpPr>
@@ -11319,7 +11481,7 @@
       </p:sp>
       <p:sp>
         <p:nvSpPr>
-          <p:cNvPr id="11" name="Rectangle 10"/>
+          <p:cNvPr id="13" name="Rectangle 12"/>
           <p:cNvSpPr/>
           <p:nvPr/>
         </p:nvSpPr>
@@ -11365,7 +11527,7 @@
       </p:sp>
       <p:sp>
         <p:nvSpPr>
-          <p:cNvPr id="12" name="TextBox 11"/>
+          <p:cNvPr id="14" name="TextBox 13"/>
           <p:cNvSpPr txBox="1"/>
           <p:nvPr/>
         </p:nvSpPr>
@@ -11400,7 +11562,7 @@
       </p:sp>
       <p:sp>
         <p:nvSpPr>
-          <p:cNvPr id="13" name="TextBox 12"/>
+          <p:cNvPr id="15" name="TextBox 14"/>
           <p:cNvSpPr txBox="1"/>
           <p:nvPr/>
         </p:nvSpPr>
@@ -11435,7 +11597,7 @@
       </p:sp>
       <p:sp>
         <p:nvSpPr>
-          <p:cNvPr id="14" name="Rectangle 13"/>
+          <p:cNvPr id="16" name="Rectangle 15"/>
           <p:cNvSpPr/>
           <p:nvPr/>
         </p:nvSpPr>
@@ -11481,7 +11643,7 @@
       </p:sp>
       <p:sp>
         <p:nvSpPr>
-          <p:cNvPr id="15" name="TextBox 14"/>
+          <p:cNvPr id="17" name="TextBox 16"/>
           <p:cNvSpPr txBox="1"/>
           <p:nvPr/>
         </p:nvSpPr>
@@ -11516,7 +11678,7 @@
       </p:sp>
       <p:sp>
         <p:nvSpPr>
-          <p:cNvPr id="16" name="TextBox 15"/>
+          <p:cNvPr id="18" name="TextBox 17"/>
           <p:cNvSpPr txBox="1"/>
           <p:nvPr/>
         </p:nvSpPr>
@@ -11551,7 +11713,7 @@
       </p:sp>
       <p:sp>
         <p:nvSpPr>
-          <p:cNvPr id="17" name="Rectangle 16"/>
+          <p:cNvPr id="19" name="Rectangle 18"/>
           <p:cNvSpPr/>
           <p:nvPr/>
         </p:nvSpPr>
@@ -11597,7 +11759,7 @@
       </p:sp>
       <p:sp>
         <p:nvSpPr>
-          <p:cNvPr id="18" name="TextBox 17"/>
+          <p:cNvPr id="20" name="TextBox 19"/>
           <p:cNvSpPr txBox="1"/>
           <p:nvPr/>
         </p:nvSpPr>
@@ -11632,7 +11794,7 @@
       </p:sp>
       <p:sp>
         <p:nvSpPr>
-          <p:cNvPr id="19" name="TextBox 18"/>
+          <p:cNvPr id="21" name="TextBox 20"/>
           <p:cNvSpPr txBox="1"/>
           <p:nvPr/>
         </p:nvSpPr>
@@ -14235,14 +14397,60 @@
       </p:sp>
       <p:sp>
         <p:nvSpPr>
-          <p:cNvPr id="7" name="TextBox 6"/>
+          <p:cNvPr id="7" name="Rectangle 6"/>
+          <p:cNvSpPr/>
+          <p:nvPr/>
+        </p:nvSpPr>
+        <p:spPr>
+          <a:xfrm>
+            <a:off x="9646920" y="347472"/>
+            <a:ext cx="2148840" cy="420624"/>
+          </a:xfrm>
+          <a:prstGeom prst="rect">
+            <a:avLst/>
+          </a:prstGeom>
+          <a:solidFill>
+            <a:srgbClr val="FFFFFF"/>
+          </a:solidFill>
+          <a:ln w="19050">
+            <a:solidFill>
+              <a:srgbClr val="E58E1A"/>
+            </a:solidFill>
+          </a:ln>
+          <a:effectLst/>
+        </p:spPr>
+        <p:style>
+          <a:lnRef idx="1">
+            <a:schemeClr val="accent1"/>
+          </a:lnRef>
+          <a:fillRef idx="3">
+            <a:schemeClr val="accent1"/>
+          </a:fillRef>
+          <a:effectRef idx="2">
+            <a:schemeClr val="accent1"/>
+          </a:effectRef>
+          <a:fontRef idx="minor">
+            <a:schemeClr val="lt1"/>
+          </a:fontRef>
+        </p:style>
+        <p:txBody>
+          <a:bodyPr rtlCol="0" anchor="ctr"/>
+          <a:lstStyle/>
+          <a:p>
+            <a:pPr algn="ctr"/>
+          </a:p>
+        </p:txBody>
+      </p:sp>
+      <p:sp>
+        <p:nvSpPr>
+          <p:cNvPr id="8" name="TextBox 7"/>
           <p:cNvSpPr txBox="1"/>
           <p:nvPr/>
         </p:nvSpPr>
         <p:spPr>
           <a:xfrm>
-            <a:off x="457200" y="329184"/>
-            <a:ext cx="9052560" cy="566928"/>
+            <a:off x="9646920" y="402336"/>
+            <a:ext cx="2148840" cy="310896"/>
           </a:xfrm>
           <a:prstGeom prst="rect">
             <a:avLst/>
@@ -14255,6 +14463,41 @@
           </a:bodyPr>
           <a:lstStyle/>
           <a:p>
+            <a:pPr algn="ctr"/>
+            <a:r>
+              <a:rPr sz="1100" b="1" i="0">
+                <a:solidFill>
+                  <a:srgbClr val="E58E1A"/>
+                </a:solidFill>
+                <a:latin typeface="Courier New"/>
+              </a:rPr>
+              <a:t>OWNER: VICTOR</a:t>
+            </a:r>
+          </a:p>
+        </p:txBody>
+      </p:sp>
+      <p:sp>
+        <p:nvSpPr>
+          <p:cNvPr id="9" name="TextBox 8"/>
+          <p:cNvSpPr txBox="1"/>
+          <p:nvPr/>
+        </p:nvSpPr>
+        <p:spPr>
+          <a:xfrm>
+            <a:off x="457200" y="329184"/>
+            <a:ext cx="9052560" cy="566928"/>
+          </a:xfrm>
+          <a:prstGeom prst="rect">
+            <a:avLst/>
+          </a:prstGeom>
+          <a:noFill/>
+        </p:spPr>
+        <p:txBody>
+          <a:bodyPr wrap="square" lIns="0" rIns="0" tIns="0" bIns="0">
+            <a:spAutoFit/>
+          </a:bodyPr>
+          <a:lstStyle/>
+          <a:p>
             <a:pPr algn="l"/>
             <a:r>
               <a:rPr sz="2300" b="1" i="0" spc="200">
@@ -14270,7 +14513,7 @@
       </p:sp>
       <p:sp>
         <p:nvSpPr>
-          <p:cNvPr id="8" name="TextBox 7"/>
+          <p:cNvPr id="10" name="TextBox 9"/>
           <p:cNvSpPr txBox="1"/>
           <p:nvPr/>
         </p:nvSpPr>
@@ -14305,7 +14548,7 @@
       </p:sp>
       <p:pic>
         <p:nvPicPr>
-          <p:cNvPr id="9" name="Picture 8" descr="g_chain.png"/>
+          <p:cNvPr id="11" name="Picture 10" descr="g_chain.png"/>
           <p:cNvPicPr>
             <a:picLocks noChangeAspect="1"/>
           </p:cNvPicPr>
@@ -14329,7 +14572,7 @@
       </p:pic>
       <p:graphicFrame>
         <p:nvGraphicFramePr>
-          <p:cNvPr id="10" name="Table 9"/>
+          <p:cNvPr id="12" name="Table 11"/>
           <p:cNvGraphicFramePr>
             <a:graphicFrameLocks noGrp="1"/>
           </p:cNvGraphicFramePr>
@@ -16129,14 +16372,60 @@
       </p:sp>
       <p:sp>
         <p:nvSpPr>
-          <p:cNvPr id="7" name="TextBox 6"/>
+          <p:cNvPr id="7" name="Rectangle 6"/>
+          <p:cNvSpPr/>
+          <p:nvPr/>
+        </p:nvSpPr>
+        <p:spPr>
+          <a:xfrm>
+            <a:off x="9646920" y="347472"/>
+            <a:ext cx="2148840" cy="420624"/>
+          </a:xfrm>
+          <a:prstGeom prst="rect">
+            <a:avLst/>
+          </a:prstGeom>
+          <a:solidFill>
+            <a:srgbClr val="FFFFFF"/>
+          </a:solidFill>
+          <a:ln w="19050">
+            <a:solidFill>
+              <a:srgbClr val="6D4BDB"/>
+            </a:solidFill>
+          </a:ln>
+          <a:effectLst/>
+        </p:spPr>
+        <p:style>
+          <a:lnRef idx="1">
+            <a:schemeClr val="accent1"/>
+          </a:lnRef>
+          <a:fillRef idx="3">
+            <a:schemeClr val="accent1"/>
+          </a:fillRef>
+          <a:effectRef idx="2">
+            <a:schemeClr val="accent1"/>
+          </a:effectRef>
+          <a:fontRef idx="minor">
+            <a:schemeClr val="lt1"/>
+          </a:fontRef>
+        </p:style>
+        <p:txBody>
+          <a:bodyPr rtlCol="0" anchor="ctr"/>
+          <a:lstStyle/>
+          <a:p>
+            <a:pPr algn="ctr"/>
+          </a:p>
+        </p:txBody>
+      </p:sp>
+      <p:sp>
+        <p:nvSpPr>
+          <p:cNvPr id="8" name="TextBox 7"/>
           <p:cNvSpPr txBox="1"/>
           <p:nvPr/>
         </p:nvSpPr>
         <p:spPr>
           <a:xfrm>
-            <a:off x="457200" y="329184"/>
-            <a:ext cx="9052560" cy="566928"/>
+            <a:off x="9646920" y="402336"/>
+            <a:ext cx="2148840" cy="310896"/>
           </a:xfrm>
           <a:prstGeom prst="rect">
             <a:avLst/>
@@ -16149,6 +16438,41 @@
           </a:bodyPr>
           <a:lstStyle/>
           <a:p>
+            <a:pPr algn="ctr"/>
+            <a:r>
+              <a:rPr sz="1100" b="1" i="0">
+                <a:solidFill>
+                  <a:srgbClr val="6D4BDB"/>
+                </a:solidFill>
+                <a:latin typeface="Courier New"/>
+              </a:rPr>
+              <a:t>OWNER: JOSIAH</a:t>
+            </a:r>
+          </a:p>
+        </p:txBody>
+      </p:sp>
+      <p:sp>
+        <p:nvSpPr>
+          <p:cNvPr id="9" name="TextBox 8"/>
+          <p:cNvSpPr txBox="1"/>
+          <p:nvPr/>
+        </p:nvSpPr>
+        <p:spPr>
+          <a:xfrm>
+            <a:off x="457200" y="329184"/>
+            <a:ext cx="9052560" cy="566928"/>
+          </a:xfrm>
+          <a:prstGeom prst="rect">
+            <a:avLst/>
+          </a:prstGeom>
+          <a:noFill/>
+        </p:spPr>
+        <p:txBody>
+          <a:bodyPr wrap="square" lIns="0" rIns="0" tIns="0" bIns="0">
+            <a:spAutoFit/>
+          </a:bodyPr>
+          <a:lstStyle/>
+          <a:p>
             <a:pPr algn="l"/>
             <a:r>
               <a:rPr sz="2300" b="1" i="0" spc="200">
@@ -16164,7 +16488,7 @@
       </p:sp>
       <p:sp>
         <p:nvSpPr>
-          <p:cNvPr id="8" name="Rectangle 7"/>
+          <p:cNvPr id="10" name="Rectangle 9"/>
           <p:cNvSpPr/>
           <p:nvPr/>
         </p:nvSpPr>
@@ -16210,7 +16534,7 @@
       </p:sp>
       <p:sp>
         <p:nvSpPr>
-          <p:cNvPr id="9" name="TextBox 8"/>
+          <p:cNvPr id="11" name="TextBox 10"/>
           <p:cNvSpPr txBox="1"/>
           <p:nvPr/>
         </p:nvSpPr>
@@ -16260,7 +16584,7 @@
       </p:sp>
       <p:sp>
         <p:nvSpPr>
-          <p:cNvPr id="10" name="Rectangle 9"/>
+          <p:cNvPr id="12" name="Rectangle 11"/>
           <p:cNvSpPr/>
           <p:nvPr/>
         </p:nvSpPr>
@@ -16306,7 +16630,7 @@
       </p:sp>
       <p:sp>
         <p:nvSpPr>
-          <p:cNvPr id="11" name="TextBox 10"/>
+          <p:cNvPr id="13" name="TextBox 12"/>
           <p:cNvSpPr txBox="1"/>
           <p:nvPr/>
         </p:nvSpPr>
@@ -16356,7 +16680,7 @@
       </p:sp>
       <p:sp>
         <p:nvSpPr>
-          <p:cNvPr id="12" name="Rectangle 11"/>
+          <p:cNvPr id="14" name="Rectangle 13"/>
           <p:cNvSpPr/>
           <p:nvPr/>
         </p:nvSpPr>
@@ -16402,7 +16726,7 @@
       </p:sp>
       <p:sp>
         <p:nvSpPr>
-          <p:cNvPr id="13" name="TextBox 12"/>
+          <p:cNvPr id="15" name="TextBox 14"/>
           <p:cNvSpPr txBox="1"/>
           <p:nvPr/>
         </p:nvSpPr>
@@ -16452,7 +16776,7 @@
       </p:sp>
       <p:sp>
         <p:nvSpPr>
-          <p:cNvPr id="14" name="TextBox 13"/>
+          <p:cNvPr id="16" name="TextBox 15"/>
           <p:cNvSpPr txBox="1"/>
           <p:nvPr/>
         </p:nvSpPr>
@@ -16487,7 +16811,7 @@
       </p:sp>
       <p:graphicFrame>
         <p:nvGraphicFramePr>
-          <p:cNvPr id="15" name="Table 14"/>
+          <p:cNvPr id="17" name="Table 16"/>
           <p:cNvGraphicFramePr>
             <a:graphicFrameLocks noGrp="1"/>
           </p:cNvGraphicFramePr>
@@ -16743,7 +17067,7 @@
       </p:graphicFrame>
       <p:sp>
         <p:nvSpPr>
-          <p:cNvPr id="16" name="TextBox 15"/>
+          <p:cNvPr id="18" name="TextBox 17"/>
           <p:cNvSpPr txBox="1"/>
           <p:nvPr/>
         </p:nvSpPr>
@@ -16989,14 +17313,60 @@
       </p:sp>
       <p:sp>
         <p:nvSpPr>
-          <p:cNvPr id="7" name="TextBox 6"/>
+          <p:cNvPr id="7" name="Rectangle 6"/>
+          <p:cNvSpPr/>
+          <p:nvPr/>
+        </p:nvSpPr>
+        <p:spPr>
+          <a:xfrm>
+            <a:off x="9646920" y="347472"/>
+            <a:ext cx="2148840" cy="420624"/>
+          </a:xfrm>
+          <a:prstGeom prst="rect">
+            <a:avLst/>
+          </a:prstGeom>
+          <a:solidFill>
+            <a:srgbClr val="FFFFFF"/>
+          </a:solidFill>
+          <a:ln w="19050">
+            <a:solidFill>
+              <a:srgbClr val="D9488C"/>
+            </a:solidFill>
+          </a:ln>
+          <a:effectLst/>
+        </p:spPr>
+        <p:style>
+          <a:lnRef idx="1">
+            <a:schemeClr val="accent1"/>
+          </a:lnRef>
+          <a:fillRef idx="3">
+            <a:schemeClr val="accent1"/>
+          </a:fillRef>
+          <a:effectRef idx="2">
+            <a:schemeClr val="accent1"/>
+          </a:effectRef>
+          <a:fontRef idx="minor">
+            <a:schemeClr val="lt1"/>
+          </a:fontRef>
+        </p:style>
+        <p:txBody>
+          <a:bodyPr rtlCol="0" anchor="ctr"/>
+          <a:lstStyle/>
+          <a:p>
+            <a:pPr algn="ctr"/>
+          </a:p>
+        </p:txBody>
+      </p:sp>
+      <p:sp>
+        <p:nvSpPr>
+          <p:cNvPr id="8" name="TextBox 7"/>
           <p:cNvSpPr txBox="1"/>
           <p:nvPr/>
         </p:nvSpPr>
         <p:spPr>
           <a:xfrm>
-            <a:off x="457200" y="329184"/>
-            <a:ext cx="9052560" cy="566928"/>
+            <a:off x="9646920" y="402336"/>
+            <a:ext cx="2148840" cy="310896"/>
           </a:xfrm>
           <a:prstGeom prst="rect">
             <a:avLst/>
@@ -17009,6 +17379,41 @@
           </a:bodyPr>
           <a:lstStyle/>
           <a:p>
+            <a:pPr algn="ctr"/>
+            <a:r>
+              <a:rPr sz="1100" b="1" i="0">
+                <a:solidFill>
+                  <a:srgbClr val="D9488C"/>
+                </a:solidFill>
+                <a:latin typeface="Courier New"/>
+              </a:rPr>
+              <a:t>OWNER: CANNON</a:t>
+            </a:r>
+          </a:p>
+        </p:txBody>
+      </p:sp>
+      <p:sp>
+        <p:nvSpPr>
+          <p:cNvPr id="9" name="TextBox 8"/>
+          <p:cNvSpPr txBox="1"/>
+          <p:nvPr/>
+        </p:nvSpPr>
+        <p:spPr>
+          <a:xfrm>
+            <a:off x="457200" y="329184"/>
+            <a:ext cx="9052560" cy="566928"/>
+          </a:xfrm>
+          <a:prstGeom prst="rect">
+            <a:avLst/>
+          </a:prstGeom>
+          <a:noFill/>
+        </p:spPr>
+        <p:txBody>
+          <a:bodyPr wrap="square" lIns="0" rIns="0" tIns="0" bIns="0">
+            <a:spAutoFit/>
+          </a:bodyPr>
+          <a:lstStyle/>
+          <a:p>
             <a:pPr algn="l"/>
             <a:r>
               <a:rPr sz="2300" b="1" i="0" spc="200">
@@ -17024,7 +17429,7 @@
       </p:sp>
       <p:graphicFrame>
         <p:nvGraphicFramePr>
-          <p:cNvPr id="8" name="Table 7"/>
+          <p:cNvPr id="10" name="Table 9"/>
           <p:cNvGraphicFramePr>
             <a:graphicFrameLocks noGrp="1"/>
           </p:cNvGraphicFramePr>
@@ -17418,7 +17823,7 @@
       </p:graphicFrame>
       <p:sp>
         <p:nvSpPr>
-          <p:cNvPr id="9" name="Rectangle 8"/>
+          <p:cNvPr id="11" name="Rectangle 10"/>
           <p:cNvSpPr/>
           <p:nvPr/>
         </p:nvSpPr>
@@ -17464,7 +17869,7 @@
       </p:sp>
       <p:sp>
         <p:nvSpPr>
-          <p:cNvPr id="10" name="TextBox 9"/>
+          <p:cNvPr id="12" name="TextBox 11"/>
           <p:cNvSpPr txBox="1"/>
           <p:nvPr/>
         </p:nvSpPr>
@@ -17773,14 +18178,60 @@
       </p:sp>
       <p:sp>
         <p:nvSpPr>
-          <p:cNvPr id="7" name="TextBox 6"/>
+          <p:cNvPr id="7" name="Rectangle 6"/>
+          <p:cNvSpPr/>
+          <p:nvPr/>
+        </p:nvSpPr>
+        <p:spPr>
+          <a:xfrm>
+            <a:off x="9646920" y="347472"/>
+            <a:ext cx="2148840" cy="420624"/>
+          </a:xfrm>
+          <a:prstGeom prst="rect">
+            <a:avLst/>
+          </a:prstGeom>
+          <a:solidFill>
+            <a:srgbClr val="FFFFFF"/>
+          </a:solidFill>
+          <a:ln w="19050">
+            <a:solidFill>
+              <a:srgbClr val="1199BD"/>
+            </a:solidFill>
+          </a:ln>
+          <a:effectLst/>
+        </p:spPr>
+        <p:style>
+          <a:lnRef idx="1">
+            <a:schemeClr val="accent1"/>
+          </a:lnRef>
+          <a:fillRef idx="3">
+            <a:schemeClr val="accent1"/>
+          </a:fillRef>
+          <a:effectRef idx="2">
+            <a:schemeClr val="accent1"/>
+          </a:effectRef>
+          <a:fontRef idx="minor">
+            <a:schemeClr val="lt1"/>
+          </a:fontRef>
+        </p:style>
+        <p:txBody>
+          <a:bodyPr rtlCol="0" anchor="ctr"/>
+          <a:lstStyle/>
+          <a:p>
+            <a:pPr algn="ctr"/>
+          </a:p>
+        </p:txBody>
+      </p:sp>
+      <p:sp>
+        <p:nvSpPr>
+          <p:cNvPr id="8" name="TextBox 7"/>
           <p:cNvSpPr txBox="1"/>
           <p:nvPr/>
         </p:nvSpPr>
         <p:spPr>
           <a:xfrm>
-            <a:off x="457200" y="329184"/>
-            <a:ext cx="9052560" cy="566928"/>
+            <a:off x="9646920" y="402336"/>
+            <a:ext cx="2148840" cy="310896"/>
           </a:xfrm>
           <a:prstGeom prst="rect">
             <a:avLst/>
@@ -17793,6 +18244,41 @@
           </a:bodyPr>
           <a:lstStyle/>
           <a:p>
+            <a:pPr algn="ctr"/>
+            <a:r>
+              <a:rPr sz="1100" b="1" i="0">
+                <a:solidFill>
+                  <a:srgbClr val="1199BD"/>
+                </a:solidFill>
+                <a:latin typeface="Courier New"/>
+              </a:rPr>
+              <a:t>OWNER: DEO</a:t>
+            </a:r>
+          </a:p>
+        </p:txBody>
+      </p:sp>
+      <p:sp>
+        <p:nvSpPr>
+          <p:cNvPr id="9" name="TextBox 8"/>
+          <p:cNvSpPr txBox="1"/>
+          <p:nvPr/>
+        </p:nvSpPr>
+        <p:spPr>
+          <a:xfrm>
+            <a:off x="457200" y="329184"/>
+            <a:ext cx="9052560" cy="566928"/>
+          </a:xfrm>
+          <a:prstGeom prst="rect">
+            <a:avLst/>
+          </a:prstGeom>
+          <a:noFill/>
+        </p:spPr>
+        <p:txBody>
+          <a:bodyPr wrap="square" lIns="0" rIns="0" tIns="0" bIns="0">
+            <a:spAutoFit/>
+          </a:bodyPr>
+          <a:lstStyle/>
+          <a:p>
             <a:pPr algn="l"/>
             <a:r>
               <a:rPr sz="2300" b="1" i="0" spc="200">
@@ -17808,7 +18294,7 @@
       </p:sp>
       <p:sp>
         <p:nvSpPr>
-          <p:cNvPr id="8" name="Rectangle 7"/>
+          <p:cNvPr id="10" name="Rectangle 9"/>
           <p:cNvSpPr/>
           <p:nvPr/>
         </p:nvSpPr>
@@ -17854,7 +18340,7 @@
       </p:sp>
       <p:sp>
         <p:nvSpPr>
-          <p:cNvPr id="9" name="TextBox 8"/>
+          <p:cNvPr id="11" name="TextBox 10"/>
           <p:cNvSpPr txBox="1"/>
           <p:nvPr/>
         </p:nvSpPr>
@@ -17904,7 +18390,7 @@
       </p:sp>
       <p:sp>
         <p:nvSpPr>
-          <p:cNvPr id="10" name="Rectangle 9"/>
+          <p:cNvPr id="12" name="Rectangle 11"/>
           <p:cNvSpPr/>
           <p:nvPr/>
         </p:nvSpPr>
@@ -17950,7 +18436,7 @@
       </p:sp>
       <p:sp>
         <p:nvSpPr>
-          <p:cNvPr id="11" name="TextBox 10"/>
+          <p:cNvPr id="13" name="TextBox 12"/>
           <p:cNvSpPr txBox="1"/>
           <p:nvPr/>
         </p:nvSpPr>
@@ -17985,7 +18471,7 @@
       </p:sp>
       <p:sp>
         <p:nvSpPr>
-          <p:cNvPr id="12" name="TextBox 11"/>
+          <p:cNvPr id="14" name="TextBox 13"/>
           <p:cNvSpPr txBox="1"/>
           <p:nvPr/>
         </p:nvSpPr>
@@ -18020,7 +18506,7 @@
       </p:sp>
       <p:sp>
         <p:nvSpPr>
-          <p:cNvPr id="13" name="Rectangle 12"/>
+          <p:cNvPr id="15" name="Rectangle 14"/>
           <p:cNvSpPr/>
           <p:nvPr/>
         </p:nvSpPr>
@@ -18066,7 +18552,7 @@
       </p:sp>
       <p:sp>
         <p:nvSpPr>
-          <p:cNvPr id="14" name="TextBox 13"/>
+          <p:cNvPr id="16" name="TextBox 15"/>
           <p:cNvSpPr txBox="1"/>
           <p:nvPr/>
         </p:nvSpPr>
@@ -18101,7 +18587,7 @@
       </p:sp>
       <p:sp>
         <p:nvSpPr>
-          <p:cNvPr id="15" name="TextBox 14"/>
+          <p:cNvPr id="17" name="TextBox 16"/>
           <p:cNvSpPr txBox="1"/>
           <p:nvPr/>
         </p:nvSpPr>
@@ -18136,7 +18622,7 @@
       </p:sp>
       <p:sp>
         <p:nvSpPr>
-          <p:cNvPr id="16" name="Rectangle 15"/>
+          <p:cNvPr id="18" name="Rectangle 17"/>
           <p:cNvSpPr/>
           <p:nvPr/>
         </p:nvSpPr>
@@ -18182,7 +18668,7 @@
       </p:sp>
       <p:sp>
         <p:nvSpPr>
-          <p:cNvPr id="17" name="TextBox 16"/>
+          <p:cNvPr id="19" name="TextBox 18"/>
           <p:cNvSpPr txBox="1"/>
           <p:nvPr/>
         </p:nvSpPr>
@@ -18217,7 +18703,7 @@
       </p:sp>
       <p:sp>
         <p:nvSpPr>
-          <p:cNvPr id="18" name="TextBox 17"/>
+          <p:cNvPr id="20" name="TextBox 19"/>
           <p:cNvSpPr txBox="1"/>
           <p:nvPr/>
         </p:nvSpPr>
@@ -18252,7 +18738,7 @@
       </p:sp>
       <p:sp>
         <p:nvSpPr>
-          <p:cNvPr id="19" name="Rectangle 18"/>
+          <p:cNvPr id="21" name="Rectangle 20"/>
           <p:cNvSpPr/>
           <p:nvPr/>
         </p:nvSpPr>
@@ -18298,7 +18784,7 @@
       </p:sp>
       <p:sp>
         <p:nvSpPr>
-          <p:cNvPr id="20" name="TextBox 19"/>
+          <p:cNvPr id="22" name="TextBox 21"/>
           <p:cNvSpPr txBox="1"/>
           <p:nvPr/>
         </p:nvSpPr>
@@ -18333,7 +18819,7 @@
       </p:sp>
       <p:sp>
         <p:nvSpPr>
-          <p:cNvPr id="21" name="TextBox 20"/>
+          <p:cNvPr id="23" name="TextBox 22"/>
           <p:cNvSpPr txBox="1"/>
           <p:nvPr/>
         </p:nvSpPr>
@@ -18368,7 +18854,7 @@
       </p:sp>
       <p:sp>
         <p:nvSpPr>
-          <p:cNvPr id="22" name="Rectangle 21"/>
+          <p:cNvPr id="24" name="Rectangle 23"/>
           <p:cNvSpPr/>
           <p:nvPr/>
         </p:nvSpPr>
@@ -18414,7 +18900,7 @@
       </p:sp>
       <p:sp>
         <p:nvSpPr>
-          <p:cNvPr id="23" name="TextBox 22"/>
+          <p:cNvPr id="25" name="TextBox 24"/>
           <p:cNvSpPr txBox="1"/>
           <p:nvPr/>
         </p:nvSpPr>
@@ -18449,7 +18935,7 @@
       </p:sp>
       <p:sp>
         <p:nvSpPr>
-          <p:cNvPr id="24" name="TextBox 23"/>
+          <p:cNvPr id="26" name="TextBox 25"/>
           <p:cNvSpPr txBox="1"/>
           <p:nvPr/>
         </p:nvSpPr>
@@ -18484,7 +18970,7 @@
       </p:sp>
       <p:sp>
         <p:nvSpPr>
-          <p:cNvPr id="25" name="Rectangle 24"/>
+          <p:cNvPr id="27" name="Rectangle 26"/>
           <p:cNvSpPr/>
           <p:nvPr/>
         </p:nvSpPr>
@@ -18530,7 +19016,7 @@
       </p:sp>
       <p:sp>
         <p:nvSpPr>
-          <p:cNvPr id="26" name="TextBox 25"/>
+          <p:cNvPr id="28" name="TextBox 27"/>
           <p:cNvSpPr txBox="1"/>
           <p:nvPr/>
         </p:nvSpPr>
@@ -18565,7 +19051,7 @@
       </p:sp>
       <p:sp>
         <p:nvSpPr>
-          <p:cNvPr id="27" name="TextBox 26"/>
+          <p:cNvPr id="29" name="TextBox 28"/>
           <p:cNvSpPr txBox="1"/>
           <p:nvPr/>
         </p:nvSpPr>
@@ -18600,7 +19086,7 @@
       </p:sp>
       <p:sp>
         <p:nvSpPr>
-          <p:cNvPr id="28" name="Rectangle 27"/>
+          <p:cNvPr id="30" name="Rectangle 29"/>
           <p:cNvSpPr/>
           <p:nvPr/>
         </p:nvSpPr>
@@ -18644,7 +19130,7 @@
       </p:sp>
       <p:sp>
         <p:nvSpPr>
-          <p:cNvPr id="29" name="TextBox 28"/>
+          <p:cNvPr id="31" name="TextBox 30"/>
           <p:cNvSpPr txBox="1"/>
           <p:nvPr/>
         </p:nvSpPr>
@@ -18890,14 +19376,60 @@
       </p:sp>
       <p:sp>
         <p:nvSpPr>
-          <p:cNvPr id="7" name="TextBox 6"/>
+          <p:cNvPr id="7" name="Rectangle 6"/>
+          <p:cNvSpPr/>
+          <p:nvPr/>
+        </p:nvSpPr>
+        <p:spPr>
+          <a:xfrm>
+            <a:off x="9646920" y="347472"/>
+            <a:ext cx="2148840" cy="420624"/>
+          </a:xfrm>
+          <a:prstGeom prst="rect">
+            <a:avLst/>
+          </a:prstGeom>
+          <a:solidFill>
+            <a:srgbClr val="FFFFFF"/>
+          </a:solidFill>
+          <a:ln w="19050">
+            <a:solidFill>
+              <a:srgbClr val="D9488C"/>
+            </a:solidFill>
+          </a:ln>
+          <a:effectLst/>
+        </p:spPr>
+        <p:style>
+          <a:lnRef idx="1">
+            <a:schemeClr val="accent1"/>
+          </a:lnRef>
+          <a:fillRef idx="3">
+            <a:schemeClr val="accent1"/>
+          </a:fillRef>
+          <a:effectRef idx="2">
+            <a:schemeClr val="accent1"/>
+          </a:effectRef>
+          <a:fontRef idx="minor">
+            <a:schemeClr val="lt1"/>
+          </a:fontRef>
+        </p:style>
+        <p:txBody>
+          <a:bodyPr rtlCol="0" anchor="ctr"/>
+          <a:lstStyle/>
+          <a:p>
+            <a:pPr algn="ctr"/>
+          </a:p>
+        </p:txBody>
+      </p:sp>
+      <p:sp>
+        <p:nvSpPr>
+          <p:cNvPr id="8" name="TextBox 7"/>
           <p:cNvSpPr txBox="1"/>
           <p:nvPr/>
         </p:nvSpPr>
         <p:spPr>
           <a:xfrm>
-            <a:off x="457200" y="329184"/>
-            <a:ext cx="9052560" cy="566928"/>
+            <a:off x="9646920" y="402336"/>
+            <a:ext cx="2148840" cy="310896"/>
           </a:xfrm>
           <a:prstGeom prst="rect">
             <a:avLst/>
@@ -18910,6 +19442,41 @@
           </a:bodyPr>
           <a:lstStyle/>
           <a:p>
+            <a:pPr algn="ctr"/>
+            <a:r>
+              <a:rPr sz="1100" b="1" i="0">
+                <a:solidFill>
+                  <a:srgbClr val="D9488C"/>
+                </a:solidFill>
+                <a:latin typeface="Courier New"/>
+              </a:rPr>
+              <a:t>OWNER: CANNON</a:t>
+            </a:r>
+          </a:p>
+        </p:txBody>
+      </p:sp>
+      <p:sp>
+        <p:nvSpPr>
+          <p:cNvPr id="9" name="TextBox 8"/>
+          <p:cNvSpPr txBox="1"/>
+          <p:nvPr/>
+        </p:nvSpPr>
+        <p:spPr>
+          <a:xfrm>
+            <a:off x="457200" y="329184"/>
+            <a:ext cx="9052560" cy="566928"/>
+          </a:xfrm>
+          <a:prstGeom prst="rect">
+            <a:avLst/>
+          </a:prstGeom>
+          <a:noFill/>
+        </p:spPr>
+        <p:txBody>
+          <a:bodyPr wrap="square" lIns="0" rIns="0" tIns="0" bIns="0">
+            <a:spAutoFit/>
+          </a:bodyPr>
+          <a:lstStyle/>
+          <a:p>
             <a:pPr algn="l"/>
             <a:r>
               <a:rPr sz="2300" b="1" i="0" spc="200">
@@ -18925,7 +19492,7 @@
       </p:sp>
       <p:pic>
         <p:nvPicPr>
-          <p:cNvPr id="8" name="Picture 7" descr="g_failtimeline.png"/>
+          <p:cNvPr id="10" name="Picture 9" descr="g_failtimeline.png"/>
           <p:cNvPicPr>
             <a:picLocks noChangeAspect="1"/>
           </p:cNvPicPr>
@@ -18949,7 +19516,7 @@
       </p:pic>
       <p:sp>
         <p:nvSpPr>
-          <p:cNvPr id="9" name="TextBox 8"/>
+          <p:cNvPr id="11" name="TextBox 10"/>
           <p:cNvSpPr txBox="1"/>
           <p:nvPr/>
         </p:nvSpPr>
@@ -22089,7 +22656,7 @@
           </a:solidFill>
           <a:ln w="19050">
             <a:solidFill>
-              <a:srgbClr val="1199BD"/>
+              <a:srgbClr val="6D4BDB"/>
             </a:solidFill>
           </a:ln>
           <a:effectLst/>
@@ -22142,11 +22709,11 @@
             <a:r>
               <a:rPr sz="1100" b="1" i="0">
                 <a:solidFill>
-                  <a:srgbClr val="1199BD"/>
+                  <a:srgbClr val="6D4BDB"/>
                 </a:solidFill>
                 <a:latin typeface="Courier New"/>
               </a:rPr>
-              <a:t>OWNER: DEO</a:t>
+              <a:t>OWNER: JOSIAH</a:t>
             </a:r>
           </a:p>
         </p:txBody>
@@ -25243,14 +25810,60 @@
       </p:sp>
       <p:sp>
         <p:nvSpPr>
-          <p:cNvPr id="36" name="TextBox 35"/>
+          <p:cNvPr id="36" name="Rectangle 35"/>
+          <p:cNvSpPr/>
+          <p:nvPr/>
+        </p:nvSpPr>
+        <p:spPr>
+          <a:xfrm>
+            <a:off x="9646920" y="347472"/>
+            <a:ext cx="2148840" cy="420624"/>
+          </a:xfrm>
+          <a:prstGeom prst="rect">
+            <a:avLst/>
+          </a:prstGeom>
+          <a:solidFill>
+            <a:srgbClr val="FFFFFF"/>
+          </a:solidFill>
+          <a:ln w="19050">
+            <a:solidFill>
+              <a:srgbClr val="E58E1A"/>
+            </a:solidFill>
+          </a:ln>
+          <a:effectLst/>
+        </p:spPr>
+        <p:style>
+          <a:lnRef idx="1">
+            <a:schemeClr val="accent1"/>
+          </a:lnRef>
+          <a:fillRef idx="3">
+            <a:schemeClr val="accent1"/>
+          </a:fillRef>
+          <a:effectRef idx="2">
+            <a:schemeClr val="accent1"/>
+          </a:effectRef>
+          <a:fontRef idx="minor">
+            <a:schemeClr val="lt1"/>
+          </a:fontRef>
+        </p:style>
+        <p:txBody>
+          <a:bodyPr rtlCol="0" anchor="ctr"/>
+          <a:lstStyle/>
+          <a:p>
+            <a:pPr algn="ctr"/>
+          </a:p>
+        </p:txBody>
+      </p:sp>
+      <p:sp>
+        <p:nvSpPr>
+          <p:cNvPr id="37" name="TextBox 36"/>
           <p:cNvSpPr txBox="1"/>
           <p:nvPr/>
         </p:nvSpPr>
         <p:spPr>
           <a:xfrm>
-            <a:off x="640080" y="457200"/>
-            <a:ext cx="10881360" cy="457200"/>
+            <a:off x="9646920" y="402336"/>
+            <a:ext cx="2148840" cy="310896"/>
           </a:xfrm>
           <a:prstGeom prst="rect">
             <a:avLst/>
@@ -25263,6 +25876,41 @@
           </a:bodyPr>
           <a:lstStyle/>
           <a:p>
+            <a:pPr algn="ctr"/>
+            <a:r>
+              <a:rPr sz="1100" b="1" i="0">
+                <a:solidFill>
+                  <a:srgbClr val="E58E1A"/>
+                </a:solidFill>
+                <a:latin typeface="Courier New"/>
+              </a:rPr>
+              <a:t>OWNER: VICTOR</a:t>
+            </a:r>
+          </a:p>
+        </p:txBody>
+      </p:sp>
+      <p:sp>
+        <p:nvSpPr>
+          <p:cNvPr id="38" name="TextBox 37"/>
+          <p:cNvSpPr txBox="1"/>
+          <p:nvPr/>
+        </p:nvSpPr>
+        <p:spPr>
+          <a:xfrm>
+            <a:off x="640080" y="457200"/>
+            <a:ext cx="10881360" cy="457200"/>
+          </a:xfrm>
+          <a:prstGeom prst="rect">
+            <a:avLst/>
+          </a:prstGeom>
+          <a:noFill/>
+        </p:spPr>
+        <p:txBody>
+          <a:bodyPr wrap="square" lIns="0" rIns="0" tIns="0" bIns="0">
+            <a:spAutoFit/>
+          </a:bodyPr>
+          <a:lstStyle/>
+          <a:p>
             <a:pPr algn="l"/>
             <a:r>
               <a:rPr sz="1600" b="1" i="0" spc="400">
@@ -25278,7 +25926,7 @@
       </p:sp>
       <p:sp>
         <p:nvSpPr>
-          <p:cNvPr id="37" name="TextBox 36"/>
+          <p:cNvPr id="39" name="TextBox 38"/>
           <p:cNvSpPr txBox="1"/>
           <p:nvPr/>
         </p:nvSpPr>
@@ -25313,7 +25961,7 @@
       </p:sp>
       <p:sp>
         <p:nvSpPr>
-          <p:cNvPr id="38" name="TextBox 37"/>
+          <p:cNvPr id="40" name="TextBox 39"/>
           <p:cNvSpPr txBox="1"/>
           <p:nvPr/>
         </p:nvSpPr>
@@ -25348,7 +25996,7 @@
       </p:sp>
       <p:sp>
         <p:nvSpPr>
-          <p:cNvPr id="39" name="Rectangle 38"/>
+          <p:cNvPr id="41" name="Rectangle 40"/>
           <p:cNvSpPr/>
           <p:nvPr/>
         </p:nvSpPr>
@@ -25394,7 +26042,7 @@
       </p:sp>
       <p:sp>
         <p:nvSpPr>
-          <p:cNvPr id="40" name="TextBox 39"/>
+          <p:cNvPr id="42" name="TextBox 41"/>
           <p:cNvSpPr txBox="1"/>
           <p:nvPr/>
         </p:nvSpPr>
@@ -25476,7 +26124,7 @@
       </p:sp>
       <p:sp>
         <p:nvSpPr>
-          <p:cNvPr id="41" name="Rectangle 40"/>
+          <p:cNvPr id="43" name="Rectangle 42"/>
           <p:cNvSpPr/>
           <p:nvPr/>
         </p:nvSpPr>
@@ -25522,7 +26170,7 @@
       </p:sp>
       <p:sp>
         <p:nvSpPr>
-          <p:cNvPr id="42" name="TextBox 41"/>
+          <p:cNvPr id="44" name="TextBox 43"/>
           <p:cNvSpPr txBox="1"/>
           <p:nvPr/>
         </p:nvSpPr>
@@ -25604,7 +26252,7 @@
       </p:sp>
       <p:sp>
         <p:nvSpPr>
-          <p:cNvPr id="43" name="Rectangle 42"/>
+          <p:cNvPr id="45" name="Rectangle 44"/>
           <p:cNvSpPr/>
           <p:nvPr/>
         </p:nvSpPr>
@@ -25650,7 +26298,7 @@
       </p:sp>
       <p:sp>
         <p:nvSpPr>
-          <p:cNvPr id="44" name="TextBox 43"/>
+          <p:cNvPr id="46" name="TextBox 45"/>
           <p:cNvSpPr txBox="1"/>
           <p:nvPr/>
         </p:nvSpPr>
@@ -25732,7 +26380,7 @@
       </p:sp>
       <p:sp>
         <p:nvSpPr>
-          <p:cNvPr id="45" name="Rectangle 44"/>
+          <p:cNvPr id="47" name="Rectangle 46"/>
           <p:cNvSpPr/>
           <p:nvPr/>
         </p:nvSpPr>
@@ -25778,7 +26426,7 @@
       </p:sp>
       <p:sp>
         <p:nvSpPr>
-          <p:cNvPr id="46" name="TextBox 45"/>
+          <p:cNvPr id="48" name="TextBox 47"/>
           <p:cNvSpPr txBox="1"/>
           <p:nvPr/>
         </p:nvSpPr>

</xml_diff>